<commit_message>
docs: ajoute une icône illustrative sur chaque diapositive (OpenMoji)
</commit_message>
<xml_diff>
--- a/campagne-delegue-lucien.pptx
+++ b/campagne-delegue-lucien.pptx
@@ -3192,7 +3192,7 @@
         <p:spPr>
           <a:xfrm>
             <a:off x="1097280" y="1371600"/>
-            <a:ext cx="10058400" cy="548640"/>
+            <a:ext cx="8229600" cy="548640"/>
           </a:xfrm>
           <a:prstGeom prst="rect">
             <a:avLst/>
@@ -3237,7 +3237,7 @@
         <p:spPr>
           <a:xfrm>
             <a:off x="1097280" y="1783080"/>
-            <a:ext cx="10058400" cy="1188720"/>
+            <a:ext cx="8229600" cy="1188720"/>
           </a:xfrm>
           <a:prstGeom prst="rect">
             <a:avLst/>
@@ -3282,7 +3282,7 @@
         <p:spPr>
           <a:xfrm>
             <a:off x="1097280" y="3429000"/>
-            <a:ext cx="9601200" cy="1097280"/>
+            <a:ext cx="8229600" cy="1097280"/>
           </a:xfrm>
           <a:prstGeom prst="rect">
             <a:avLst/>
@@ -3328,7 +3328,7 @@
         <p:spPr>
           <a:xfrm>
             <a:off x="1097280" y="5029200"/>
-            <a:ext cx="9601200" cy="457200"/>
+            <a:ext cx="8229600" cy="457200"/>
           </a:xfrm>
           <a:prstGeom prst="rect">
             <a:avLst/>
@@ -3364,6 +3364,74 @@
           </a:p>
         </p:txBody>
       </p:sp>
+      <p:sp>
+        <p:nvSpPr>
+          <p:cNvPr id="8" name="Oval 7"/>
+          <p:cNvSpPr/>
+          <p:nvPr/>
+        </p:nvSpPr>
+        <p:spPr>
+          <a:xfrm>
+            <a:off x="8738006" y="645566"/>
+            <a:ext cx="2457907" cy="2457907"/>
+          </a:xfrm>
+          <a:prstGeom prst="ellipse">
+            <a:avLst/>
+          </a:prstGeom>
+          <a:solidFill>
+            <a:srgbClr val="2A315C"/>
+          </a:solidFill>
+          <a:ln>
+            <a:noFill/>
+          </a:ln>
+          <a:effectLst/>
+        </p:spPr>
+        <p:style>
+          <a:lnRef idx="1">
+            <a:schemeClr val="accent1"/>
+          </a:lnRef>
+          <a:fillRef idx="3">
+            <a:schemeClr val="accent1"/>
+          </a:fillRef>
+          <a:effectRef idx="2">
+            <a:schemeClr val="accent1"/>
+          </a:effectRef>
+          <a:fontRef idx="minor">
+            <a:schemeClr val="lt1"/>
+          </a:fontRef>
+        </p:style>
+        <p:txBody>
+          <a:bodyPr rtlCol="0" anchor="ctr"/>
+          <a:lstStyle/>
+          <a:p>
+            <a:pPr algn="ctr"/>
+          </a:p>
+        </p:txBody>
+      </p:sp>
+      <p:pic>
+        <p:nvPicPr>
+          <p:cNvPr id="9" name="Picture 8" descr="1F4E3.png"/>
+          <p:cNvPicPr>
+            <a:picLocks noChangeAspect="1"/>
+          </p:cNvPicPr>
+          <p:nvPr/>
+        </p:nvPicPr>
+        <p:blipFill>
+          <a:blip r:embed="rId2"/>
+          <a:stretch>
+            <a:fillRect/>
+          </a:stretch>
+        </p:blipFill>
+        <p:spPr>
+          <a:xfrm>
+            <a:off x="9006840" y="914399"/>
+            <a:ext cx="1920240" cy="1920240"/>
+          </a:xfrm>
+          <a:prstGeom prst="rect">
+            <a:avLst/>
+          </a:prstGeom>
+        </p:spPr>
+      </p:pic>
     </p:spTree>
   </p:cSld>
   <p:clrMapOvr>
@@ -3524,7 +3592,52 @@
         <p:spPr>
           <a:xfrm>
             <a:off x="822960" y="1234440"/>
-            <a:ext cx="10515600" cy="914400"/>
+            <a:ext cx="8961120" cy="1737360"/>
+          </a:xfrm>
+          <a:prstGeom prst="rect">
+            <a:avLst/>
+          </a:prstGeom>
+          <a:noFill/>
+        </p:spPr>
+        <p:txBody>
+          <a:bodyPr wrap="square" anchor="t">
+            <a:spAutoFit/>
+          </a:bodyPr>
+          <a:lstStyle/>
+          <a:p>
+            <a:pPr algn="l">
+              <a:lnSpc>
+                <a:spcPct val="105000"/>
+              </a:lnSpc>
+              <a:spcBef>
+                <a:spcPts val="0"/>
+              </a:spcBef>
+              <a:spcAft>
+                <a:spcPts val="1400"/>
+              </a:spcAft>
+            </a:pPr>
+            <a:r>
+              <a:rPr sz="4000" b="1">
+                <a:solidFill>
+                  <a:srgbClr val="161B3A"/>
+                </a:solidFill>
+                <a:latin typeface="Verdana"/>
+              </a:rPr>
+              <a:t>Je ne promets pas de changer le collège</a:t>
+            </a:r>
+          </a:p>
+        </p:txBody>
+      </p:sp>
+      <p:sp>
+        <p:nvSpPr>
+          <p:cNvPr id="6" name="TextBox 5"/>
+          <p:cNvSpPr txBox="1"/>
+          <p:nvPr/>
+        </p:nvSpPr>
+        <p:spPr>
+          <a:xfrm>
+            <a:off x="822960" y="2880360"/>
+            <a:ext cx="4754880" cy="2377440"/>
           </a:xfrm>
           <a:prstGeom prst="rect">
             <a:avLst/>
@@ -3549,27 +3662,316 @@
               </a:spcAft>
             </a:pPr>
             <a:r>
-              <a:rPr sz="4000" b="1">
-                <a:solidFill>
-                  <a:srgbClr val="161B3A"/>
+              <a:rPr sz="1700" b="0">
+                <a:solidFill>
+                  <a:srgbClr val="5A607A"/>
                 </a:solidFill>
                 <a:latin typeface="Verdana"/>
               </a:rPr>
-              <a:t>Je ne promets pas de changer le collège</a:t>
-            </a:r>
-          </a:p>
-        </p:txBody>
-      </p:sp>
-      <p:sp>
-        <p:nvSpPr>
-          <p:cNvPr id="6" name="TextBox 5"/>
+              <a:t>L'année prochaine, ce sera toujours :</a:t>
+            </a:r>
+          </a:p>
+          <a:p>
+            <a:pPr algn="l">
+              <a:lnSpc>
+                <a:spcPct val="115000"/>
+              </a:lnSpc>
+              <a:spcBef>
+                <a:spcPts val="1200"/>
+              </a:spcBef>
+              <a:spcAft>
+                <a:spcPts val="1400"/>
+              </a:spcAft>
+            </a:pPr>
+            <a:r>
+              <a:rPr sz="2100" b="1">
+                <a:solidFill>
+                  <a:srgbClr val="2A315C"/>
+                </a:solidFill>
+                <a:latin typeface="Verdana"/>
+              </a:rPr>
+              <a:t>Le même bâtiment</a:t>
+            </a:r>
+          </a:p>
+          <a:p>
+            <a:pPr algn="l">
+              <a:lnSpc>
+                <a:spcPct val="115000"/>
+              </a:lnSpc>
+              <a:spcBef>
+                <a:spcPts val="400"/>
+              </a:spcBef>
+              <a:spcAft>
+                <a:spcPts val="1400"/>
+              </a:spcAft>
+            </a:pPr>
+            <a:r>
+              <a:rPr sz="2100" b="1">
+                <a:solidFill>
+                  <a:srgbClr val="2A315C"/>
+                </a:solidFill>
+                <a:latin typeface="Verdana"/>
+              </a:rPr>
+              <a:t>Les mêmes contrôles</a:t>
+            </a:r>
+          </a:p>
+          <a:p>
+            <a:pPr algn="l">
+              <a:lnSpc>
+                <a:spcPct val="115000"/>
+              </a:lnSpc>
+              <a:spcBef>
+                <a:spcPts val="400"/>
+              </a:spcBef>
+              <a:spcAft>
+                <a:spcPts val="1400"/>
+              </a:spcAft>
+            </a:pPr>
+            <a:r>
+              <a:rPr sz="2100" b="1">
+                <a:solidFill>
+                  <a:srgbClr val="2A315C"/>
+                </a:solidFill>
+                <a:latin typeface="Verdana"/>
+              </a:rPr>
+              <a:t>La même cantine le jeudi</a:t>
+            </a:r>
+          </a:p>
+        </p:txBody>
+      </p:sp>
+      <p:sp>
+        <p:nvSpPr>
+          <p:cNvPr id="7" name="Rectangle 6"/>
+          <p:cNvSpPr/>
+          <p:nvPr/>
+        </p:nvSpPr>
+        <p:spPr>
+          <a:xfrm>
+            <a:off x="5989320" y="2651760"/>
+            <a:ext cx="3703320" cy="3017520"/>
+          </a:xfrm>
+          <a:prstGeom prst="rect">
+            <a:avLst/>
+          </a:prstGeom>
+          <a:solidFill>
+            <a:srgbClr val="F4F5F9"/>
+          </a:solidFill>
+          <a:ln>
+            <a:noFill/>
+          </a:ln>
+          <a:effectLst/>
+        </p:spPr>
+        <p:style>
+          <a:lnRef idx="1">
+            <a:schemeClr val="accent1"/>
+          </a:lnRef>
+          <a:fillRef idx="3">
+            <a:schemeClr val="accent1"/>
+          </a:fillRef>
+          <a:effectRef idx="2">
+            <a:schemeClr val="accent1"/>
+          </a:effectRef>
+          <a:fontRef idx="minor">
+            <a:schemeClr val="lt1"/>
+          </a:fontRef>
+        </p:style>
+        <p:txBody>
+          <a:bodyPr rtlCol="0" anchor="ctr"/>
+          <a:lstStyle/>
+          <a:p>
+            <a:pPr algn="ctr"/>
+          </a:p>
+        </p:txBody>
+      </p:sp>
+      <p:sp>
+        <p:nvSpPr>
+          <p:cNvPr id="8" name="Rectangle 7"/>
+          <p:cNvSpPr/>
+          <p:nvPr/>
+        </p:nvSpPr>
+        <p:spPr>
+          <a:xfrm>
+            <a:off x="5989320" y="2651760"/>
+            <a:ext cx="63500" cy="3017520"/>
+          </a:xfrm>
+          <a:prstGeom prst="rect">
+            <a:avLst/>
+          </a:prstGeom>
+          <a:solidFill>
+            <a:srgbClr val="F57C00"/>
+          </a:solidFill>
+          <a:ln>
+            <a:noFill/>
+          </a:ln>
+          <a:effectLst/>
+        </p:spPr>
+        <p:style>
+          <a:lnRef idx="1">
+            <a:schemeClr val="accent1"/>
+          </a:lnRef>
+          <a:fillRef idx="3">
+            <a:schemeClr val="accent1"/>
+          </a:fillRef>
+          <a:effectRef idx="2">
+            <a:schemeClr val="accent1"/>
+          </a:effectRef>
+          <a:fontRef idx="minor">
+            <a:schemeClr val="lt1"/>
+          </a:fontRef>
+        </p:style>
+        <p:txBody>
+          <a:bodyPr rtlCol="0" anchor="ctr"/>
+          <a:lstStyle/>
+          <a:p>
+            <a:pPr algn="ctr"/>
+          </a:p>
+        </p:txBody>
+      </p:sp>
+      <p:sp>
+        <p:nvSpPr>
+          <p:cNvPr id="9" name="TextBox 8"/>
           <p:cNvSpPr txBox="1"/>
           <p:nvPr/>
         </p:nvSpPr>
         <p:spPr>
           <a:xfrm>
-            <a:off x="822960" y="2377440"/>
-            <a:ext cx="4754880" cy="2377440"/>
+            <a:off x="6355080" y="2880360"/>
+            <a:ext cx="3108960" cy="2560320"/>
+          </a:xfrm>
+          <a:prstGeom prst="rect">
+            <a:avLst/>
+          </a:prstGeom>
+          <a:noFill/>
+        </p:spPr>
+        <p:txBody>
+          <a:bodyPr wrap="square" anchor="t">
+            <a:spAutoFit/>
+          </a:bodyPr>
+          <a:lstStyle/>
+          <a:p>
+            <a:pPr algn="l">
+              <a:lnSpc>
+                <a:spcPct val="110000"/>
+              </a:lnSpc>
+              <a:spcBef>
+                <a:spcPts val="0"/>
+              </a:spcBef>
+              <a:spcAft>
+                <a:spcPts val="400"/>
+              </a:spcAft>
+            </a:pPr>
+            <a:r>
+              <a:rPr sz="1400" b="0">
+                <a:solidFill>
+                  <a:srgbClr val="5A607A"/>
+                </a:solidFill>
+                <a:latin typeface="Verdana"/>
+              </a:rPr>
+              <a:t>Une seule chose peut changer :</a:t>
+            </a:r>
+          </a:p>
+          <a:p>
+            <a:pPr algn="l">
+              <a:lnSpc>
+                <a:spcPct val="110000"/>
+              </a:lnSpc>
+              <a:spcBef>
+                <a:spcPts val="0"/>
+              </a:spcBef>
+              <a:spcAft>
+                <a:spcPts val="400"/>
+              </a:spcAft>
+            </a:pPr>
+            <a:r>
+              <a:rPr sz="1900" b="1">
+                <a:solidFill>
+                  <a:srgbClr val="161B3A"/>
+                </a:solidFill>
+                <a:latin typeface="Verdana"/>
+              </a:rPr>
+              <a:t>est-ce que vos idées arrivent jusqu'à la réunion, ou est-ce qu'elles restent dans la cour ?</a:t>
+            </a:r>
+          </a:p>
+        </p:txBody>
+      </p:sp>
+      <p:sp>
+        <p:nvSpPr>
+          <p:cNvPr id="10" name="Oval 9"/>
+          <p:cNvSpPr/>
+          <p:nvPr/>
+        </p:nvSpPr>
+        <p:spPr>
+          <a:xfrm>
+            <a:off x="9769449" y="3002889"/>
+            <a:ext cx="2223820" cy="2223820"/>
+          </a:xfrm>
+          <a:prstGeom prst="ellipse">
+            <a:avLst/>
+          </a:prstGeom>
+          <a:solidFill>
+            <a:srgbClr val="FCE7CF"/>
+          </a:solidFill>
+          <a:ln>
+            <a:noFill/>
+          </a:ln>
+          <a:effectLst/>
+        </p:spPr>
+        <p:style>
+          <a:lnRef idx="1">
+            <a:schemeClr val="accent1"/>
+          </a:lnRef>
+          <a:fillRef idx="3">
+            <a:schemeClr val="accent1"/>
+          </a:fillRef>
+          <a:effectRef idx="2">
+            <a:schemeClr val="accent1"/>
+          </a:effectRef>
+          <a:fontRef idx="minor">
+            <a:schemeClr val="lt1"/>
+          </a:fontRef>
+        </p:style>
+        <p:txBody>
+          <a:bodyPr rtlCol="0" anchor="ctr"/>
+          <a:lstStyle/>
+          <a:p>
+            <a:pPr algn="ctr"/>
+          </a:p>
+        </p:txBody>
+      </p:sp>
+      <p:pic>
+        <p:nvPicPr>
+          <p:cNvPr id="11" name="Picture 10" descr="1F3EB.png"/>
+          <p:cNvPicPr>
+            <a:picLocks noChangeAspect="1"/>
+          </p:cNvPicPr>
+          <p:nvPr/>
+        </p:nvPicPr>
+        <p:blipFill>
+          <a:blip r:embed="rId2"/>
+          <a:stretch>
+            <a:fillRect/>
+          </a:stretch>
+        </p:blipFill>
+        <p:spPr>
+          <a:xfrm>
+            <a:off x="10012680" y="3246120"/>
+            <a:ext cx="1737360" cy="1737360"/>
+          </a:xfrm>
+          <a:prstGeom prst="rect">
+            <a:avLst/>
+          </a:prstGeom>
+        </p:spPr>
+      </p:pic>
+      <p:sp>
+        <p:nvSpPr>
+          <p:cNvPr id="12" name="TextBox 11"/>
+          <p:cNvSpPr txBox="1"/>
+          <p:nvPr/>
+        </p:nvSpPr>
+        <p:spPr>
+          <a:xfrm>
+            <a:off x="822960" y="6309360"/>
+            <a:ext cx="5486400" cy="365760"/>
           </a:xfrm>
           <a:prstGeom prst="rect">
             <a:avLst/>
@@ -3594,272 +3996,6 @@
               </a:spcAft>
             </a:pPr>
             <a:r>
-              <a:rPr sz="1700" b="0">
-                <a:solidFill>
-                  <a:srgbClr val="5A607A"/>
-                </a:solidFill>
-                <a:latin typeface="Verdana"/>
-              </a:rPr>
-              <a:t>L'année prochaine, ce sera toujours :</a:t>
-            </a:r>
-          </a:p>
-          <a:p>
-            <a:pPr algn="l">
-              <a:lnSpc>
-                <a:spcPct val="115000"/>
-              </a:lnSpc>
-              <a:spcBef>
-                <a:spcPts val="1000"/>
-              </a:spcBef>
-              <a:spcAft>
-                <a:spcPts val="1400"/>
-              </a:spcAft>
-            </a:pPr>
-            <a:r>
-              <a:rPr sz="2100" b="1">
-                <a:solidFill>
-                  <a:srgbClr val="2A315C"/>
-                </a:solidFill>
-                <a:latin typeface="Verdana"/>
-              </a:rPr>
-              <a:t>Le même bâtiment</a:t>
-            </a:r>
-          </a:p>
-          <a:p>
-            <a:pPr algn="l">
-              <a:lnSpc>
-                <a:spcPct val="115000"/>
-              </a:lnSpc>
-              <a:spcBef>
-                <a:spcPts val="400"/>
-              </a:spcBef>
-              <a:spcAft>
-                <a:spcPts val="1400"/>
-              </a:spcAft>
-            </a:pPr>
-            <a:r>
-              <a:rPr sz="2100" b="1">
-                <a:solidFill>
-                  <a:srgbClr val="2A315C"/>
-                </a:solidFill>
-                <a:latin typeface="Verdana"/>
-              </a:rPr>
-              <a:t>Les mêmes contrôles</a:t>
-            </a:r>
-          </a:p>
-          <a:p>
-            <a:pPr algn="l">
-              <a:lnSpc>
-                <a:spcPct val="115000"/>
-              </a:lnSpc>
-              <a:spcBef>
-                <a:spcPts val="400"/>
-              </a:spcBef>
-              <a:spcAft>
-                <a:spcPts val="1400"/>
-              </a:spcAft>
-            </a:pPr>
-            <a:r>
-              <a:rPr sz="2100" b="1">
-                <a:solidFill>
-                  <a:srgbClr val="2A315C"/>
-                </a:solidFill>
-                <a:latin typeface="Verdana"/>
-              </a:rPr>
-              <a:t>La même cantine le jeudi</a:t>
-            </a:r>
-          </a:p>
-        </p:txBody>
-      </p:sp>
-      <p:sp>
-        <p:nvSpPr>
-          <p:cNvPr id="7" name="Rectangle 6"/>
-          <p:cNvSpPr/>
-          <p:nvPr/>
-        </p:nvSpPr>
-        <p:spPr>
-          <a:xfrm>
-            <a:off x="6035040" y="2286000"/>
-            <a:ext cx="5303520" cy="2926080"/>
-          </a:xfrm>
-          <a:prstGeom prst="rect">
-            <a:avLst/>
-          </a:prstGeom>
-          <a:solidFill>
-            <a:srgbClr val="F4F5F9"/>
-          </a:solidFill>
-          <a:ln>
-            <a:noFill/>
-          </a:ln>
-          <a:effectLst/>
-        </p:spPr>
-        <p:style>
-          <a:lnRef idx="1">
-            <a:schemeClr val="accent1"/>
-          </a:lnRef>
-          <a:fillRef idx="3">
-            <a:schemeClr val="accent1"/>
-          </a:fillRef>
-          <a:effectRef idx="2">
-            <a:schemeClr val="accent1"/>
-          </a:effectRef>
-          <a:fontRef idx="minor">
-            <a:schemeClr val="lt1"/>
-          </a:fontRef>
-        </p:style>
-        <p:txBody>
-          <a:bodyPr rtlCol="0" anchor="ctr"/>
-          <a:lstStyle/>
-          <a:p>
-            <a:pPr algn="ctr"/>
-          </a:p>
-        </p:txBody>
-      </p:sp>
-      <p:sp>
-        <p:nvSpPr>
-          <p:cNvPr id="8" name="Rectangle 7"/>
-          <p:cNvSpPr/>
-          <p:nvPr/>
-        </p:nvSpPr>
-        <p:spPr>
-          <a:xfrm>
-            <a:off x="6035040" y="2286000"/>
-            <a:ext cx="63500" cy="2926080"/>
-          </a:xfrm>
-          <a:prstGeom prst="rect">
-            <a:avLst/>
-          </a:prstGeom>
-          <a:solidFill>
-            <a:srgbClr val="F57C00"/>
-          </a:solidFill>
-          <a:ln>
-            <a:noFill/>
-          </a:ln>
-          <a:effectLst/>
-        </p:spPr>
-        <p:style>
-          <a:lnRef idx="1">
-            <a:schemeClr val="accent1"/>
-          </a:lnRef>
-          <a:fillRef idx="3">
-            <a:schemeClr val="accent1"/>
-          </a:fillRef>
-          <a:effectRef idx="2">
-            <a:schemeClr val="accent1"/>
-          </a:effectRef>
-          <a:fontRef idx="minor">
-            <a:schemeClr val="lt1"/>
-          </a:fontRef>
-        </p:style>
-        <p:txBody>
-          <a:bodyPr rtlCol="0" anchor="ctr"/>
-          <a:lstStyle/>
-          <a:p>
-            <a:pPr algn="ctr"/>
-          </a:p>
-        </p:txBody>
-      </p:sp>
-      <p:sp>
-        <p:nvSpPr>
-          <p:cNvPr id="9" name="TextBox 8"/>
-          <p:cNvSpPr txBox="1"/>
-          <p:nvPr/>
-        </p:nvSpPr>
-        <p:spPr>
-          <a:xfrm>
-            <a:off x="6492240" y="2651760"/>
-            <a:ext cx="4572000" cy="2194560"/>
-          </a:xfrm>
-          <a:prstGeom prst="rect">
-            <a:avLst/>
-          </a:prstGeom>
-          <a:noFill/>
-        </p:spPr>
-        <p:txBody>
-          <a:bodyPr wrap="square" anchor="t">
-            <a:spAutoFit/>
-          </a:bodyPr>
-          <a:lstStyle/>
-          <a:p>
-            <a:pPr algn="l">
-              <a:lnSpc>
-                <a:spcPct val="110000"/>
-              </a:lnSpc>
-              <a:spcBef>
-                <a:spcPts val="0"/>
-              </a:spcBef>
-              <a:spcAft>
-                <a:spcPts val="1400"/>
-              </a:spcAft>
-            </a:pPr>
-            <a:r>
-              <a:rPr sz="1700" b="0">
-                <a:solidFill>
-                  <a:srgbClr val="5A607A"/>
-                </a:solidFill>
-                <a:latin typeface="Verdana"/>
-              </a:rPr>
-              <a:t>Une seule chose peut changer :</a:t>
-            </a:r>
-          </a:p>
-          <a:p>
-            <a:pPr algn="l">
-              <a:lnSpc>
-                <a:spcPct val="110000"/>
-              </a:lnSpc>
-              <a:spcBef>
-                <a:spcPts val="0"/>
-              </a:spcBef>
-              <a:spcAft>
-                <a:spcPts val="1400"/>
-              </a:spcAft>
-            </a:pPr>
-            <a:r>
-              <a:rPr sz="2600" b="1">
-                <a:solidFill>
-                  <a:srgbClr val="161B3A"/>
-                </a:solidFill>
-                <a:latin typeface="Verdana"/>
-              </a:rPr>
-              <a:t>est-ce que vos idées arrivent jusqu'à la réunion, ou est-ce qu'elles restent dans la cour ?</a:t>
-            </a:r>
-          </a:p>
-        </p:txBody>
-      </p:sp>
-      <p:sp>
-        <p:nvSpPr>
-          <p:cNvPr id="10" name="TextBox 9"/>
-          <p:cNvSpPr txBox="1"/>
-          <p:nvPr/>
-        </p:nvSpPr>
-        <p:spPr>
-          <a:xfrm>
-            <a:off x="822960" y="6263640"/>
-            <a:ext cx="7315200" cy="365760"/>
-          </a:xfrm>
-          <a:prstGeom prst="rect">
-            <a:avLst/>
-          </a:prstGeom>
-          <a:noFill/>
-        </p:spPr>
-        <p:txBody>
-          <a:bodyPr wrap="square" anchor="t">
-            <a:spAutoFit/>
-          </a:bodyPr>
-          <a:lstStyle/>
-          <a:p>
-            <a:pPr algn="l">
-              <a:lnSpc>
-                <a:spcPct val="115000"/>
-              </a:lnSpc>
-              <a:spcBef>
-                <a:spcPts val="0"/>
-              </a:spcBef>
-              <a:spcAft>
-                <a:spcPts val="1400"/>
-              </a:spcAft>
-            </a:pPr>
-            <a:r>
               <a:rPr sz="1100" b="0">
                 <a:solidFill>
                   <a:srgbClr val="5A607A"/>
@@ -3873,14 +4009,14 @@
       </p:sp>
       <p:sp>
         <p:nvSpPr>
-          <p:cNvPr id="11" name="TextBox 10"/>
+          <p:cNvPr id="13" name="TextBox 12"/>
           <p:cNvSpPr txBox="1"/>
           <p:nvPr/>
         </p:nvSpPr>
         <p:spPr>
           <a:xfrm>
-            <a:off x="10881360" y="6263640"/>
-            <a:ext cx="548640" cy="365760"/>
+            <a:off x="11292840" y="6309360"/>
+            <a:ext cx="685800" cy="365760"/>
           </a:xfrm>
           <a:prstGeom prst="rect">
             <a:avLst/>
@@ -4076,7 +4212,7 @@
         <p:spPr>
           <a:xfrm>
             <a:off x="822960" y="1234440"/>
-            <a:ext cx="10515600" cy="822960"/>
+            <a:ext cx="8961120" cy="822960"/>
           </a:xfrm>
           <a:prstGeom prst="rect">
             <a:avLst/>
@@ -4120,8 +4256,8 @@
         </p:nvSpPr>
         <p:spPr>
           <a:xfrm>
-            <a:off x="822960" y="2377440"/>
-            <a:ext cx="3291840" cy="2103120"/>
+            <a:off x="822960" y="2331720"/>
+            <a:ext cx="2743200" cy="2377440"/>
           </a:xfrm>
           <a:prstGeom prst="rect">
             <a:avLst/>
@@ -4164,7 +4300,7 @@
         </p:nvSpPr>
         <p:spPr>
           <a:xfrm>
-            <a:off x="1188720" y="2651760"/>
+            <a:off x="1143000" y="2606040"/>
             <a:ext cx="914400" cy="548640"/>
           </a:xfrm>
           <a:prstGeom prst="rect">
@@ -4209,8 +4345,8 @@
         </p:nvSpPr>
         <p:spPr>
           <a:xfrm>
-            <a:off x="1188720" y="3429000"/>
-            <a:ext cx="2651760" cy="914400"/>
+            <a:off x="1143000" y="3383280"/>
+            <a:ext cx="2148840" cy="1097280"/>
           </a:xfrm>
           <a:prstGeom prst="rect">
             <a:avLst/>
@@ -4235,7 +4371,7 @@
               </a:spcAft>
             </a:pPr>
             <a:r>
-              <a:rPr sz="1700" b="1">
+              <a:rPr sz="1600" b="1">
                 <a:solidFill>
                   <a:srgbClr val="2A315C"/>
                 </a:solidFill>
@@ -4254,8 +4390,8 @@
         </p:nvSpPr>
         <p:spPr>
           <a:xfrm>
-            <a:off x="4343400" y="2377440"/>
-            <a:ext cx="3291840" cy="2103120"/>
+            <a:off x="3886200" y="2331720"/>
+            <a:ext cx="2743200" cy="2377440"/>
           </a:xfrm>
           <a:prstGeom prst="rect">
             <a:avLst/>
@@ -4298,7 +4434,7 @@
         </p:nvSpPr>
         <p:spPr>
           <a:xfrm>
-            <a:off x="4709160" y="2651760"/>
+            <a:off x="4206240" y="2606040"/>
             <a:ext cx="914400" cy="548640"/>
           </a:xfrm>
           <a:prstGeom prst="rect">
@@ -4343,8 +4479,8 @@
         </p:nvSpPr>
         <p:spPr>
           <a:xfrm>
-            <a:off x="4709160" y="3429000"/>
-            <a:ext cx="2651760" cy="914400"/>
+            <a:off x="4206240" y="3383280"/>
+            <a:ext cx="2148840" cy="1097280"/>
           </a:xfrm>
           <a:prstGeom prst="rect">
             <a:avLst/>
@@ -4369,7 +4505,7 @@
               </a:spcAft>
             </a:pPr>
             <a:r>
-              <a:rPr sz="1700" b="1">
+              <a:rPr sz="1600" b="1">
                 <a:solidFill>
                   <a:srgbClr val="2A315C"/>
                 </a:solidFill>
@@ -4388,8 +4524,8 @@
         </p:nvSpPr>
         <p:spPr>
           <a:xfrm>
-            <a:off x="7863840" y="2377440"/>
-            <a:ext cx="3291840" cy="2103120"/>
+            <a:off x="6949440" y="2331720"/>
+            <a:ext cx="2743200" cy="2377440"/>
           </a:xfrm>
           <a:prstGeom prst="rect">
             <a:avLst/>
@@ -4432,7 +4568,7 @@
         </p:nvSpPr>
         <p:spPr>
           <a:xfrm>
-            <a:off x="8229600" y="2651760"/>
+            <a:off x="7269479" y="2606040"/>
             <a:ext cx="914400" cy="548640"/>
           </a:xfrm>
           <a:prstGeom prst="rect">
@@ -4477,8 +4613,8 @@
         </p:nvSpPr>
         <p:spPr>
           <a:xfrm>
-            <a:off x="8229600" y="3429000"/>
-            <a:ext cx="2651760" cy="914400"/>
+            <a:off x="7269479" y="3383280"/>
+            <a:ext cx="2148840" cy="1097280"/>
           </a:xfrm>
           <a:prstGeom prst="rect">
             <a:avLst/>
@@ -4503,7 +4639,7 @@
               </a:spcAft>
             </a:pPr>
             <a:r>
-              <a:rPr sz="1700" b="1">
+              <a:rPr sz="1600" b="1">
                 <a:solidFill>
                   <a:srgbClr val="FFFFFF"/>
                 </a:solidFill>
@@ -4522,8 +4658,8 @@
         </p:nvSpPr>
         <p:spPr>
           <a:xfrm>
-            <a:off x="822960" y="4754880"/>
-            <a:ext cx="10515600" cy="731520"/>
+            <a:off x="822960" y="4892040"/>
+            <a:ext cx="8778240" cy="914400"/>
           </a:xfrm>
           <a:prstGeom prst="rect">
             <a:avLst/>
@@ -4548,7 +4684,7 @@
               </a:spcAft>
             </a:pPr>
             <a:r>
-              <a:rPr sz="2600" b="1">
+              <a:rPr sz="2400" b="1">
                 <a:solidFill>
                   <a:srgbClr val="161B3A"/>
                 </a:solidFill>
@@ -4563,14 +4699,14 @@
                 <a:spcPct val="115000"/>
               </a:lnSpc>
               <a:spcBef>
-                <a:spcPts val="800"/>
+                <a:spcPts val="600"/>
               </a:spcBef>
               <a:spcAft>
                 <a:spcPts val="1400"/>
               </a:spcAft>
             </a:pPr>
             <a:r>
-              <a:rPr sz="1700" b="0">
+              <a:rPr sz="1600" b="0">
                 <a:solidFill>
                   <a:srgbClr val="5A607A"/>
                 </a:solidFill>
@@ -4583,14 +4719,82 @@
       </p:sp>
       <p:sp>
         <p:nvSpPr>
-          <p:cNvPr id="16" name="TextBox 15"/>
+          <p:cNvPr id="16" name="Oval 15"/>
+          <p:cNvSpPr/>
+          <p:nvPr/>
+        </p:nvSpPr>
+        <p:spPr>
+          <a:xfrm>
+            <a:off x="9827971" y="4021531"/>
+            <a:ext cx="2106777" cy="2106777"/>
+          </a:xfrm>
+          <a:prstGeom prst="ellipse">
+            <a:avLst/>
+          </a:prstGeom>
+          <a:solidFill>
+            <a:srgbClr val="FCE7CF"/>
+          </a:solidFill>
+          <a:ln>
+            <a:noFill/>
+          </a:ln>
+          <a:effectLst/>
+        </p:spPr>
+        <p:style>
+          <a:lnRef idx="1">
+            <a:schemeClr val="accent1"/>
+          </a:lnRef>
+          <a:fillRef idx="3">
+            <a:schemeClr val="accent1"/>
+          </a:fillRef>
+          <a:effectRef idx="2">
+            <a:schemeClr val="accent1"/>
+          </a:effectRef>
+          <a:fontRef idx="minor">
+            <a:schemeClr val="lt1"/>
+          </a:fontRef>
+        </p:style>
+        <p:txBody>
+          <a:bodyPr rtlCol="0" anchor="ctr"/>
+          <a:lstStyle/>
+          <a:p>
+            <a:pPr algn="ctr"/>
+          </a:p>
+        </p:txBody>
+      </p:sp>
+      <p:pic>
+        <p:nvPicPr>
+          <p:cNvPr id="17" name="Picture 16" descr="1F4AC.png"/>
+          <p:cNvPicPr>
+            <a:picLocks noChangeAspect="1"/>
+          </p:cNvPicPr>
+          <p:nvPr/>
+        </p:nvPicPr>
+        <p:blipFill>
+          <a:blip r:embed="rId2"/>
+          <a:stretch>
+            <a:fillRect/>
+          </a:stretch>
+        </p:blipFill>
+        <p:spPr>
+          <a:xfrm>
+            <a:off x="10058400" y="4251959"/>
+            <a:ext cx="1645920" cy="1645920"/>
+          </a:xfrm>
+          <a:prstGeom prst="rect">
+            <a:avLst/>
+          </a:prstGeom>
+        </p:spPr>
+      </p:pic>
+      <p:sp>
+        <p:nvSpPr>
+          <p:cNvPr id="18" name="TextBox 17"/>
           <p:cNvSpPr txBox="1"/>
           <p:nvPr/>
         </p:nvSpPr>
         <p:spPr>
           <a:xfrm>
-            <a:off x="822960" y="6263640"/>
-            <a:ext cx="7315200" cy="365760"/>
+            <a:off x="822960" y="6309360"/>
+            <a:ext cx="5486400" cy="365760"/>
           </a:xfrm>
           <a:prstGeom prst="rect">
             <a:avLst/>
@@ -4628,14 +4832,14 @@
       </p:sp>
       <p:sp>
         <p:nvSpPr>
-          <p:cNvPr id="17" name="TextBox 16"/>
+          <p:cNvPr id="19" name="TextBox 18"/>
           <p:cNvSpPr txBox="1"/>
           <p:nvPr/>
         </p:nvSpPr>
         <p:spPr>
           <a:xfrm>
-            <a:off x="10881360" y="6263640"/>
-            <a:ext cx="548640" cy="365760"/>
+            <a:off x="11292840" y="6309360"/>
+            <a:ext cx="685800" cy="365760"/>
           </a:xfrm>
           <a:prstGeom prst="rect">
             <a:avLst/>
@@ -4875,7 +5079,7 @@
         <p:spPr>
           <a:xfrm>
             <a:off x="822960" y="1234440"/>
-            <a:ext cx="10515600" cy="1463040"/>
+            <a:ext cx="8961120" cy="1737360"/>
           </a:xfrm>
           <a:prstGeom prst="rect">
             <a:avLst/>
@@ -4890,7 +5094,7 @@
           <a:p>
             <a:pPr algn="l">
               <a:lnSpc>
-                <a:spcPct val="110000"/>
+                <a:spcPct val="105000"/>
               </a:lnSpc>
               <a:spcBef>
                 <a:spcPts val="0"/>
@@ -4900,7 +5104,7 @@
               </a:spcAft>
             </a:pPr>
             <a:r>
-              <a:rPr sz="4000" b="1">
+              <a:rPr sz="3800" b="1">
                 <a:solidFill>
                   <a:srgbClr val="161B3A"/>
                 </a:solidFill>
@@ -4919,8 +5123,8 @@
         </p:nvSpPr>
         <p:spPr>
           <a:xfrm>
-            <a:off x="822960" y="3017520"/>
-            <a:ext cx="10515600" cy="1463040"/>
+            <a:off x="822960" y="3154680"/>
+            <a:ext cx="8961120" cy="2011680"/>
           </a:xfrm>
           <a:prstGeom prst="rect">
             <a:avLst/>
@@ -4945,7 +5149,7 @@
               </a:spcAft>
             </a:pPr>
             <a:r>
-              <a:rPr sz="2200" b="0">
+              <a:rPr sz="2100" b="0">
                 <a:solidFill>
                   <a:srgbClr val="5A607A"/>
                 </a:solidFill>
@@ -4967,7 +5171,7 @@
               </a:spcAft>
             </a:pPr>
             <a:r>
-              <a:rPr sz="3000" b="1">
+              <a:rPr sz="2800" b="1">
                 <a:solidFill>
                   <a:srgbClr val="F57C00"/>
                 </a:solidFill>
@@ -4980,14 +5184,82 @@
       </p:sp>
       <p:sp>
         <p:nvSpPr>
-          <p:cNvPr id="8" name="TextBox 7"/>
+          <p:cNvPr id="8" name="Oval 7"/>
+          <p:cNvSpPr/>
+          <p:nvPr/>
+        </p:nvSpPr>
+        <p:spPr>
+          <a:xfrm>
+            <a:off x="9769449" y="3460089"/>
+            <a:ext cx="2223820" cy="2223820"/>
+          </a:xfrm>
+          <a:prstGeom prst="ellipse">
+            <a:avLst/>
+          </a:prstGeom>
+          <a:solidFill>
+            <a:srgbClr val="FCE7CF"/>
+          </a:solidFill>
+          <a:ln>
+            <a:noFill/>
+          </a:ln>
+          <a:effectLst/>
+        </p:spPr>
+        <p:style>
+          <a:lnRef idx="1">
+            <a:schemeClr val="accent1"/>
+          </a:lnRef>
+          <a:fillRef idx="3">
+            <a:schemeClr val="accent1"/>
+          </a:fillRef>
+          <a:effectRef idx="2">
+            <a:schemeClr val="accent1"/>
+          </a:effectRef>
+          <a:fontRef idx="minor">
+            <a:schemeClr val="lt1"/>
+          </a:fontRef>
+        </p:style>
+        <p:txBody>
+          <a:bodyPr rtlCol="0" anchor="ctr"/>
+          <a:lstStyle/>
+          <a:p>
+            <a:pPr algn="ctr"/>
+          </a:p>
+        </p:txBody>
+      </p:sp>
+      <p:pic>
+        <p:nvPicPr>
+          <p:cNvPr id="9" name="Picture 8" descr="1F4DD.png"/>
+          <p:cNvPicPr>
+            <a:picLocks noChangeAspect="1"/>
+          </p:cNvPicPr>
+          <p:nvPr/>
+        </p:nvPicPr>
+        <p:blipFill>
+          <a:blip r:embed="rId2"/>
+          <a:stretch>
+            <a:fillRect/>
+          </a:stretch>
+        </p:blipFill>
+        <p:spPr>
+          <a:xfrm>
+            <a:off x="10012680" y="3703320"/>
+            <a:ext cx="1737360" cy="1737360"/>
+          </a:xfrm>
+          <a:prstGeom prst="rect">
+            <a:avLst/>
+          </a:prstGeom>
+        </p:spPr>
+      </p:pic>
+      <p:sp>
+        <p:nvSpPr>
+          <p:cNvPr id="10" name="TextBox 9"/>
           <p:cNvSpPr txBox="1"/>
           <p:nvPr/>
         </p:nvSpPr>
         <p:spPr>
           <a:xfrm>
-            <a:off x="822960" y="6263640"/>
-            <a:ext cx="7315200" cy="365760"/>
+            <a:off x="822960" y="6309360"/>
+            <a:ext cx="5486400" cy="365760"/>
           </a:xfrm>
           <a:prstGeom prst="rect">
             <a:avLst/>
@@ -5025,14 +5297,14 @@
       </p:sp>
       <p:sp>
         <p:nvSpPr>
-          <p:cNvPr id="9" name="TextBox 8"/>
+          <p:cNvPr id="11" name="TextBox 10"/>
           <p:cNvSpPr txBox="1"/>
           <p:nvPr/>
         </p:nvSpPr>
         <p:spPr>
           <a:xfrm>
-            <a:off x="10881360" y="6263640"/>
-            <a:ext cx="548640" cy="365760"/>
+            <a:off x="11292840" y="6309360"/>
+            <a:ext cx="685800" cy="365760"/>
           </a:xfrm>
           <a:prstGeom prst="rect">
             <a:avLst/>
@@ -5272,7 +5544,7 @@
         <p:spPr>
           <a:xfrm>
             <a:off x="822960" y="1234440"/>
-            <a:ext cx="10515600" cy="914400"/>
+            <a:ext cx="4937760" cy="822960"/>
           </a:xfrm>
           <a:prstGeom prst="rect">
             <a:avLst/>
@@ -5303,7 +5575,7 @@
                 </a:solidFill>
                 <a:latin typeface="Verdana"/>
               </a:rPr>
-              <a:t>Une boîte à idées dans la classe</a:t>
+              <a:t>Une boîte à idées</a:t>
             </a:r>
           </a:p>
         </p:txBody>
@@ -5316,8 +5588,8 @@
         </p:nvSpPr>
         <p:spPr>
           <a:xfrm>
-            <a:off x="822960" y="2286000"/>
-            <a:ext cx="4937760" cy="3108960"/>
+            <a:off x="822960" y="2331720"/>
+            <a:ext cx="4754880" cy="3108960"/>
           </a:xfrm>
           <a:prstGeom prst="rect">
             <a:avLst/>
@@ -5357,7 +5629,7 @@
                 <a:spcPct val="115000"/>
               </a:lnSpc>
               <a:spcBef>
-                <a:spcPts val="1200"/>
+                <a:spcPts val="1400"/>
               </a:spcBef>
               <a:spcAft>
                 <a:spcPts val="1400"/>
@@ -5427,8 +5699,8 @@
         </p:nvSpPr>
         <p:spPr>
           <a:xfrm>
-            <a:off x="6126480" y="2194560"/>
-            <a:ext cx="5212080" cy="3200400"/>
+            <a:off x="5989320" y="1828800"/>
+            <a:ext cx="3703320" cy="3931920"/>
           </a:xfrm>
           <a:prstGeom prst="rect">
             <a:avLst/>
@@ -5471,8 +5743,8 @@
         </p:nvSpPr>
         <p:spPr>
           <a:xfrm>
-            <a:off x="6583680" y="2606040"/>
-            <a:ext cx="4297680" cy="2468880"/>
+            <a:off x="6355080" y="2148840"/>
+            <a:ext cx="3063240" cy="3383280"/>
           </a:xfrm>
           <a:prstGeom prst="rect">
             <a:avLst/>
@@ -5493,7 +5765,7 @@
                 <a:spcPts val="0"/>
               </a:spcBef>
               <a:spcAft>
-                <a:spcPts val="1400"/>
+                <a:spcPts val="400"/>
               </a:spcAft>
             </a:pPr>
             <a:r>
@@ -5512,20 +5784,42 @@
                 <a:spcPct val="110000"/>
               </a:lnSpc>
               <a:spcBef>
-                <a:spcPts val="1200"/>
+                <a:spcPts val="1400"/>
               </a:spcBef>
               <a:spcAft>
-                <a:spcPts val="1400"/>
+                <a:spcPts val="400"/>
               </a:spcAft>
             </a:pPr>
             <a:r>
-              <a:rPr sz="2600" b="1">
+              <a:rPr sz="2200" b="1">
                 <a:solidFill>
                   <a:srgbClr val="FFFFFF"/>
                 </a:solidFill>
                 <a:latin typeface="Verdana"/>
               </a:rPr>
               <a:t>Je lis tout.</a:t>
+            </a:r>
+          </a:p>
+          <a:p>
+            <a:pPr algn="l">
+              <a:lnSpc>
+                <a:spcPct val="110000"/>
+              </a:lnSpc>
+              <a:spcBef>
+                <a:spcPts val="800"/>
+              </a:spcBef>
+              <a:spcAft>
+                <a:spcPts val="400"/>
+              </a:spcAft>
+            </a:pPr>
+            <a:r>
+              <a:rPr sz="1800" b="1">
+                <a:solidFill>
+                  <a:srgbClr val="FFFFFF"/>
+                </a:solidFill>
+                <a:latin typeface="Verdana"/>
+              </a:rPr>
+              <a:t>Je remonte tout au prof principal, dans l'ordre.</a:t>
             </a:r>
           </a:p>
           <a:p>
@@ -5537,33 +5831,11 @@
                 <a:spcPts val="600"/>
               </a:spcBef>
               <a:spcAft>
-                <a:spcPts val="1400"/>
+                <a:spcPts val="400"/>
               </a:spcAft>
             </a:pPr>
             <a:r>
-              <a:rPr sz="2200" b="1">
-                <a:solidFill>
-                  <a:srgbClr val="FFFFFF"/>
-                </a:solidFill>
-                <a:latin typeface="Verdana"/>
-              </a:rPr>
-              <a:t>Je remonte tout au prof principal, dans l'ordre.</a:t>
-            </a:r>
-          </a:p>
-          <a:p>
-            <a:pPr algn="l">
-              <a:lnSpc>
-                <a:spcPct val="110000"/>
-              </a:lnSpc>
-              <a:spcBef>
-                <a:spcPts val="600"/>
-              </a:spcBef>
-              <a:spcAft>
-                <a:spcPts val="1400"/>
-              </a:spcAft>
-            </a:pPr>
-            <a:r>
-              <a:rPr sz="2200" b="1">
+              <a:rPr sz="1800" b="1">
                 <a:solidFill>
                   <a:srgbClr val="FFFFFF"/>
                 </a:solidFill>
@@ -5576,14 +5848,82 @@
       </p:sp>
       <p:sp>
         <p:nvSpPr>
-          <p:cNvPr id="10" name="TextBox 9"/>
+          <p:cNvPr id="10" name="Oval 9"/>
+          <p:cNvSpPr/>
+          <p:nvPr/>
+        </p:nvSpPr>
+        <p:spPr>
+          <a:xfrm>
+            <a:off x="9769449" y="2545689"/>
+            <a:ext cx="2223820" cy="2223820"/>
+          </a:xfrm>
+          <a:prstGeom prst="ellipse">
+            <a:avLst/>
+          </a:prstGeom>
+          <a:solidFill>
+            <a:srgbClr val="FCE7CF"/>
+          </a:solidFill>
+          <a:ln>
+            <a:noFill/>
+          </a:ln>
+          <a:effectLst/>
+        </p:spPr>
+        <p:style>
+          <a:lnRef idx="1">
+            <a:schemeClr val="accent1"/>
+          </a:lnRef>
+          <a:fillRef idx="3">
+            <a:schemeClr val="accent1"/>
+          </a:fillRef>
+          <a:effectRef idx="2">
+            <a:schemeClr val="accent1"/>
+          </a:effectRef>
+          <a:fontRef idx="minor">
+            <a:schemeClr val="lt1"/>
+          </a:fontRef>
+        </p:style>
+        <p:txBody>
+          <a:bodyPr rtlCol="0" anchor="ctr"/>
+          <a:lstStyle/>
+          <a:p>
+            <a:pPr algn="ctr"/>
+          </a:p>
+        </p:txBody>
+      </p:sp>
+      <p:pic>
+        <p:nvPicPr>
+          <p:cNvPr id="11" name="Picture 10" descr="1F4A1.png"/>
+          <p:cNvPicPr>
+            <a:picLocks noChangeAspect="1"/>
+          </p:cNvPicPr>
+          <p:nvPr/>
+        </p:nvPicPr>
+        <p:blipFill>
+          <a:blip r:embed="rId2"/>
+          <a:stretch>
+            <a:fillRect/>
+          </a:stretch>
+        </p:blipFill>
+        <p:spPr>
+          <a:xfrm>
+            <a:off x="10012680" y="2788920"/>
+            <a:ext cx="1737360" cy="1737360"/>
+          </a:xfrm>
+          <a:prstGeom prst="rect">
+            <a:avLst/>
+          </a:prstGeom>
+        </p:spPr>
+      </p:pic>
+      <p:sp>
+        <p:nvSpPr>
+          <p:cNvPr id="12" name="TextBox 11"/>
           <p:cNvSpPr txBox="1"/>
           <p:nvPr/>
         </p:nvSpPr>
         <p:spPr>
           <a:xfrm>
-            <a:off x="822960" y="6263640"/>
-            <a:ext cx="7315200" cy="365760"/>
+            <a:off x="822960" y="6309360"/>
+            <a:ext cx="5486400" cy="365760"/>
           </a:xfrm>
           <a:prstGeom prst="rect">
             <a:avLst/>
@@ -5621,14 +5961,14 @@
       </p:sp>
       <p:sp>
         <p:nvSpPr>
-          <p:cNvPr id="11" name="TextBox 10"/>
+          <p:cNvPr id="13" name="TextBox 12"/>
           <p:cNvSpPr txBox="1"/>
           <p:nvPr/>
         </p:nvSpPr>
         <p:spPr>
           <a:xfrm>
-            <a:off x="10881360" y="6263640"/>
-            <a:ext cx="548640" cy="365760"/>
+            <a:off x="11292840" y="6309360"/>
+            <a:ext cx="685800" cy="365760"/>
           </a:xfrm>
           <a:prstGeom prst="rect">
             <a:avLst/>
@@ -5823,8 +6163,8 @@
         </p:nvSpPr>
         <p:spPr>
           <a:xfrm>
-            <a:off x="822960" y="1234440"/>
-            <a:ext cx="10515600" cy="1828800"/>
+            <a:off x="822960" y="1280160"/>
+            <a:ext cx="8961120" cy="1828800"/>
           </a:xfrm>
           <a:prstGeom prst="rect">
             <a:avLst/>
@@ -5849,7 +6189,7 @@
               </a:spcAft>
             </a:pPr>
             <a:r>
-              <a:rPr sz="3000" b="1">
+              <a:rPr sz="2800" b="1">
                 <a:solidFill>
                   <a:srgbClr val="F57C00"/>
                 </a:solidFill>
@@ -5868,8 +6208,8 @@
         </p:nvSpPr>
         <p:spPr>
           <a:xfrm>
-            <a:off x="822960" y="3566160"/>
-            <a:ext cx="10515600" cy="1828800"/>
+            <a:off x="822960" y="3657600"/>
+            <a:ext cx="8961120" cy="1828800"/>
           </a:xfrm>
           <a:prstGeom prst="rect">
             <a:avLst/>
@@ -5916,7 +6256,7 @@
               </a:spcAft>
             </a:pPr>
             <a:r>
-              <a:rPr sz="2200" b="0">
+              <a:rPr sz="2100" b="0">
                 <a:solidFill>
                   <a:srgbClr val="5A607A"/>
                 </a:solidFill>
@@ -5929,14 +6269,82 @@
       </p:sp>
       <p:sp>
         <p:nvSpPr>
-          <p:cNvPr id="7" name="TextBox 6"/>
+          <p:cNvPr id="7" name="Oval 6"/>
+          <p:cNvSpPr/>
+          <p:nvPr/>
+        </p:nvSpPr>
+        <p:spPr>
+          <a:xfrm>
+            <a:off x="9769449" y="1265529"/>
+            <a:ext cx="2223820" cy="2223820"/>
+          </a:xfrm>
+          <a:prstGeom prst="ellipse">
+            <a:avLst/>
+          </a:prstGeom>
+          <a:solidFill>
+            <a:srgbClr val="FCE7CF"/>
+          </a:solidFill>
+          <a:ln>
+            <a:noFill/>
+          </a:ln>
+          <a:effectLst/>
+        </p:spPr>
+        <p:style>
+          <a:lnRef idx="1">
+            <a:schemeClr val="accent1"/>
+          </a:lnRef>
+          <a:fillRef idx="3">
+            <a:schemeClr val="accent1"/>
+          </a:fillRef>
+          <a:effectRef idx="2">
+            <a:schemeClr val="accent1"/>
+          </a:effectRef>
+          <a:fontRef idx="minor">
+            <a:schemeClr val="lt1"/>
+          </a:fontRef>
+        </p:style>
+        <p:txBody>
+          <a:bodyPr rtlCol="0" anchor="ctr"/>
+          <a:lstStyle/>
+          <a:p>
+            <a:pPr algn="ctr"/>
+          </a:p>
+        </p:txBody>
+      </p:sp>
+      <p:pic>
+        <p:nvPicPr>
+          <p:cNvPr id="8" name="Picture 7" descr="1F64B.png"/>
+          <p:cNvPicPr>
+            <a:picLocks noChangeAspect="1"/>
+          </p:cNvPicPr>
+          <p:nvPr/>
+        </p:nvPicPr>
+        <p:blipFill>
+          <a:blip r:embed="rId2"/>
+          <a:stretch>
+            <a:fillRect/>
+          </a:stretch>
+        </p:blipFill>
+        <p:spPr>
+          <a:xfrm>
+            <a:off x="10012680" y="1508760"/>
+            <a:ext cx="1737360" cy="1737360"/>
+          </a:xfrm>
+          <a:prstGeom prst="rect">
+            <a:avLst/>
+          </a:prstGeom>
+        </p:spPr>
+      </p:pic>
+      <p:sp>
+        <p:nvSpPr>
+          <p:cNvPr id="9" name="TextBox 8"/>
           <p:cNvSpPr txBox="1"/>
           <p:nvPr/>
         </p:nvSpPr>
         <p:spPr>
           <a:xfrm>
-            <a:off x="822960" y="6263640"/>
-            <a:ext cx="7315200" cy="365760"/>
+            <a:off x="822960" y="6309360"/>
+            <a:ext cx="5486400" cy="365760"/>
           </a:xfrm>
           <a:prstGeom prst="rect">
             <a:avLst/>
@@ -5974,14 +6382,14 @@
       </p:sp>
       <p:sp>
         <p:nvSpPr>
-          <p:cNvPr id="8" name="TextBox 7"/>
+          <p:cNvPr id="10" name="TextBox 9"/>
           <p:cNvSpPr txBox="1"/>
           <p:nvPr/>
         </p:nvSpPr>
         <p:spPr>
           <a:xfrm>
-            <a:off x="10881360" y="6263640"/>
-            <a:ext cx="548640" cy="365760"/>
+            <a:off x="11292840" y="6309360"/>
+            <a:ext cx="685800" cy="365760"/>
           </a:xfrm>
           <a:prstGeom prst="rect">
             <a:avLst/>
@@ -6088,7 +6496,7 @@
         <p:spPr>
           <a:xfrm>
             <a:off x="1097280" y="1097280"/>
-            <a:ext cx="10058400" cy="457200"/>
+            <a:ext cx="8229600" cy="457200"/>
           </a:xfrm>
           <a:prstGeom prst="rect">
             <a:avLst/>
@@ -6133,7 +6541,7 @@
         <p:spPr>
           <a:xfrm>
             <a:off x="1097280" y="2103120"/>
-            <a:ext cx="10058400" cy="2377440"/>
+            <a:ext cx="7589520" cy="2377440"/>
           </a:xfrm>
           <a:prstGeom prst="rect">
             <a:avLst/>
@@ -6158,7 +6566,7 @@
               </a:spcAft>
             </a:pPr>
             <a:r>
-              <a:rPr sz="6000" b="1">
+              <a:rPr sz="5800" b="1">
                 <a:solidFill>
                   <a:srgbClr val="FFFFFF"/>
                 </a:solidFill>
@@ -6214,6 +6622,74 @@
           </a:p>
         </p:txBody>
       </p:sp>
+      <p:sp>
+        <p:nvSpPr>
+          <p:cNvPr id="6" name="Oval 5"/>
+          <p:cNvSpPr/>
+          <p:nvPr/>
+        </p:nvSpPr>
+        <p:spPr>
+          <a:xfrm>
+            <a:off x="8138160" y="1371600"/>
+            <a:ext cx="2926080" cy="2926080"/>
+          </a:xfrm>
+          <a:prstGeom prst="ellipse">
+            <a:avLst/>
+          </a:prstGeom>
+          <a:solidFill>
+            <a:srgbClr val="2A315C"/>
+          </a:solidFill>
+          <a:ln>
+            <a:noFill/>
+          </a:ln>
+          <a:effectLst/>
+        </p:spPr>
+        <p:style>
+          <a:lnRef idx="1">
+            <a:schemeClr val="accent1"/>
+          </a:lnRef>
+          <a:fillRef idx="3">
+            <a:schemeClr val="accent1"/>
+          </a:fillRef>
+          <a:effectRef idx="2">
+            <a:schemeClr val="accent1"/>
+          </a:effectRef>
+          <a:fontRef idx="minor">
+            <a:schemeClr val="lt1"/>
+          </a:fontRef>
+        </p:style>
+        <p:txBody>
+          <a:bodyPr rtlCol="0" anchor="ctr"/>
+          <a:lstStyle/>
+          <a:p>
+            <a:pPr algn="ctr"/>
+          </a:p>
+        </p:txBody>
+      </p:sp>
+      <p:pic>
+        <p:nvPicPr>
+          <p:cNvPr id="7" name="Picture 6" descr="2B06.png"/>
+          <p:cNvPicPr>
+            <a:picLocks noChangeAspect="1"/>
+          </p:cNvPicPr>
+          <p:nvPr/>
+        </p:nvPicPr>
+        <p:blipFill>
+          <a:blip r:embed="rId2"/>
+          <a:stretch>
+            <a:fillRect/>
+          </a:stretch>
+        </p:blipFill>
+        <p:spPr>
+          <a:xfrm>
+            <a:off x="8458200" y="1691640"/>
+            <a:ext cx="2286000" cy="2286000"/>
+          </a:xfrm>
+          <a:prstGeom prst="rect">
+            <a:avLst/>
+          </a:prstGeom>
+        </p:spPr>
+      </p:pic>
     </p:spTree>
   </p:cSld>
   <p:clrMapOvr>
@@ -6328,8 +6804,8 @@
         </p:nvSpPr>
         <p:spPr>
           <a:xfrm>
-            <a:off x="822960" y="1371600"/>
-            <a:ext cx="10515600" cy="1188720"/>
+            <a:off x="822960" y="1234440"/>
+            <a:ext cx="8961120" cy="1371600"/>
           </a:xfrm>
           <a:prstGeom prst="rect">
             <a:avLst/>
@@ -6354,7 +6830,7 @@
               </a:spcAft>
             </a:pPr>
             <a:r>
-              <a:rPr sz="3200" b="0">
+              <a:rPr sz="3000" b="0">
                 <a:solidFill>
                   <a:srgbClr val="5A607A"/>
                 </a:solidFill>
@@ -6369,14 +6845,14 @@
                 <a:spcPct val="115000"/>
               </a:lnSpc>
               <a:spcBef>
-                <a:spcPts val="1200"/>
+                <a:spcPts val="1000"/>
               </a:spcBef>
               <a:spcAft>
                 <a:spcPts val="1400"/>
               </a:spcAft>
             </a:pPr>
             <a:r>
-              <a:rPr sz="6000" b="1">
+              <a:rPr sz="5600" b="1">
                 <a:solidFill>
                   <a:srgbClr val="161B3A"/>
                 </a:solidFill>
@@ -6439,8 +6915,8 @@
         </p:nvSpPr>
         <p:spPr>
           <a:xfrm>
-            <a:off x="1280160" y="4251960"/>
-            <a:ext cx="4206240" cy="1097280"/>
+            <a:off x="1280160" y="3931920"/>
+            <a:ext cx="4206240" cy="1645920"/>
           </a:xfrm>
           <a:prstGeom prst="rect">
             <a:avLst/>
@@ -6448,7 +6924,7 @@
           <a:noFill/>
         </p:spPr>
         <p:txBody>
-          <a:bodyPr wrap="square" anchor="t">
+          <a:bodyPr wrap="square" anchor="ctr">
             <a:spAutoFit/>
           </a:bodyPr>
           <a:lstStyle/>
@@ -6465,7 +6941,7 @@
               </a:spcAft>
             </a:pPr>
             <a:r>
-              <a:rPr sz="2200" b="1">
+              <a:rPr sz="2000" b="1">
                 <a:solidFill>
                   <a:srgbClr val="FFFFFF"/>
                 </a:solidFill>
@@ -6484,8 +6960,8 @@
         </p:nvSpPr>
         <p:spPr>
           <a:xfrm>
-            <a:off x="6309360" y="3931920"/>
-            <a:ext cx="5029200" cy="1645920"/>
+            <a:off x="5989320" y="3931920"/>
+            <a:ext cx="3703320" cy="1645920"/>
           </a:xfrm>
           <a:prstGeom prst="rect">
             <a:avLst/>
@@ -6528,8 +7004,8 @@
         </p:nvSpPr>
         <p:spPr>
           <a:xfrm>
-            <a:off x="6766560" y="4480560"/>
-            <a:ext cx="4114800" cy="822960"/>
+            <a:off x="6446520" y="3931920"/>
+            <a:ext cx="3154680" cy="1645920"/>
           </a:xfrm>
           <a:prstGeom prst="rect">
             <a:avLst/>
@@ -6537,7 +7013,7 @@
           <a:noFill/>
         </p:spPr>
         <p:txBody>
-          <a:bodyPr wrap="square" anchor="t">
+          <a:bodyPr wrap="square" anchor="ctr">
             <a:spAutoFit/>
           </a:bodyPr>
           <a:lstStyle/>
@@ -6554,7 +7030,7 @@
               </a:spcAft>
             </a:pPr>
             <a:r>
-              <a:rPr sz="3400" b="1">
+              <a:rPr sz="2800" b="1">
                 <a:solidFill>
                   <a:srgbClr val="FFFFFF"/>
                 </a:solidFill>
@@ -6567,14 +7043,82 @@
       </p:sp>
       <p:sp>
         <p:nvSpPr>
-          <p:cNvPr id="9" name="TextBox 8"/>
+          <p:cNvPr id="9" name="Oval 8"/>
+          <p:cNvSpPr/>
+          <p:nvPr/>
+        </p:nvSpPr>
+        <p:spPr>
+          <a:xfrm>
+            <a:off x="9769449" y="1265529"/>
+            <a:ext cx="2223820" cy="2223820"/>
+          </a:xfrm>
+          <a:prstGeom prst="ellipse">
+            <a:avLst/>
+          </a:prstGeom>
+          <a:solidFill>
+            <a:srgbClr val="FCE7CF"/>
+          </a:solidFill>
+          <a:ln>
+            <a:noFill/>
+          </a:ln>
+          <a:effectLst/>
+        </p:spPr>
+        <p:style>
+          <a:lnRef idx="1">
+            <a:schemeClr val="accent1"/>
+          </a:lnRef>
+          <a:fillRef idx="3">
+            <a:schemeClr val="accent1"/>
+          </a:fillRef>
+          <a:effectRef idx="2">
+            <a:schemeClr val="accent1"/>
+          </a:effectRef>
+          <a:fontRef idx="minor">
+            <a:schemeClr val="lt1"/>
+          </a:fontRef>
+        </p:style>
+        <p:txBody>
+          <a:bodyPr rtlCol="0" anchor="ctr"/>
+          <a:lstStyle/>
+          <a:p>
+            <a:pPr algn="ctr"/>
+          </a:p>
+        </p:txBody>
+      </p:sp>
+      <p:pic>
+        <p:nvPicPr>
+          <p:cNvPr id="10" name="Picture 9" descr="1F5F3.png"/>
+          <p:cNvPicPr>
+            <a:picLocks noChangeAspect="1"/>
+          </p:cNvPicPr>
+          <p:nvPr/>
+        </p:nvPicPr>
+        <p:blipFill>
+          <a:blip r:embed="rId2"/>
+          <a:stretch>
+            <a:fillRect/>
+          </a:stretch>
+        </p:blipFill>
+        <p:spPr>
+          <a:xfrm>
+            <a:off x="10012680" y="1508760"/>
+            <a:ext cx="1737360" cy="1737360"/>
+          </a:xfrm>
+          <a:prstGeom prst="rect">
+            <a:avLst/>
+          </a:prstGeom>
+        </p:spPr>
+      </p:pic>
+      <p:sp>
+        <p:nvSpPr>
+          <p:cNvPr id="11" name="TextBox 10"/>
           <p:cNvSpPr txBox="1"/>
           <p:nvPr/>
         </p:nvSpPr>
         <p:spPr>
           <a:xfrm>
-            <a:off x="822960" y="6263640"/>
-            <a:ext cx="7315200" cy="365760"/>
+            <a:off x="822960" y="6309360"/>
+            <a:ext cx="5486400" cy="365760"/>
           </a:xfrm>
           <a:prstGeom prst="rect">
             <a:avLst/>
@@ -6612,14 +7156,14 @@
       </p:sp>
       <p:sp>
         <p:nvSpPr>
-          <p:cNvPr id="10" name="TextBox 9"/>
+          <p:cNvPr id="12" name="TextBox 11"/>
           <p:cNvSpPr txBox="1"/>
           <p:nvPr/>
         </p:nvSpPr>
         <p:spPr>
           <a:xfrm>
-            <a:off x="10881360" y="6263640"/>
-            <a:ext cx="548640" cy="365760"/>
+            <a:off x="11292840" y="6309360"/>
+            <a:ext cx="685800" cy="365760"/>
           </a:xfrm>
           <a:prstGeom prst="rect">
             <a:avLst/>

</xml_diff>

<commit_message>
docs: photos plein écran sur chaque diapositive (licences créditées)
</commit_message>
<xml_diff>
--- a/campagne-delegue-lucien.pptx
+++ b/campagne-delegue-lucien.pptx
@@ -3095,9 +3095,33 @@
         <p:nvPr/>
       </p:nvGrpSpPr>
       <p:grpSpPr/>
-      <p:sp>
-        <p:nvSpPr>
-          <p:cNvPr id="2" name="Rectangle 1"/>
+      <p:pic>
+        <p:nvPicPr>
+          <p:cNvPr id="2" name="Picture 1" descr="s1.jpg"/>
+          <p:cNvPicPr>
+            <a:picLocks noChangeAspect="1"/>
+          </p:cNvPicPr>
+          <p:nvPr/>
+        </p:nvPicPr>
+        <p:blipFill>
+          <a:blip r:embed="rId2"/>
+          <a:stretch>
+            <a:fillRect/>
+          </a:stretch>
+        </p:blipFill>
+        <p:spPr>
+          <a:xfrm>
+            <a:off x="0" y="-1142885"/>
+            <a:ext cx="12191695" cy="9143771"/>
+          </a:xfrm>
+          <a:prstGeom prst="rect">
+            <a:avLst/>
+          </a:prstGeom>
+        </p:spPr>
+      </p:pic>
+      <p:sp>
+        <p:nvSpPr>
+          <p:cNvPr id="3" name="Rectangle 2"/>
           <p:cNvSpPr/>
           <p:nvPr/>
         </p:nvSpPr>
@@ -3110,7 +3134,9 @@
             <a:avLst/>
           </a:prstGeom>
           <a:solidFill>
-            <a:srgbClr val="161B3A"/>
+            <a:srgbClr val="161B3A">
+              <a:alpha val="57999"/>
+            </a:srgbClr>
           </a:solidFill>
           <a:ln>
             <a:noFill/>
@@ -3141,7 +3167,7 @@
       </p:sp>
       <p:sp>
         <p:nvSpPr>
-          <p:cNvPr id="3" name="Rectangle 2"/>
+          <p:cNvPr id="4" name="Rectangle 3"/>
           <p:cNvSpPr/>
           <p:nvPr/>
         </p:nvSpPr>
@@ -3185,7 +3211,7 @@
       </p:sp>
       <p:sp>
         <p:nvSpPr>
-          <p:cNvPr id="4" name="TextBox 3"/>
+          <p:cNvPr id="5" name="TextBox 4"/>
           <p:cNvSpPr txBox="1"/>
           <p:nvPr/>
         </p:nvSpPr>
@@ -3230,7 +3256,7 @@
       </p:sp>
       <p:sp>
         <p:nvSpPr>
-          <p:cNvPr id="5" name="TextBox 4"/>
+          <p:cNvPr id="6" name="TextBox 5"/>
           <p:cNvSpPr txBox="1"/>
           <p:nvPr/>
         </p:nvSpPr>
@@ -3275,14 +3301,14 @@
       </p:sp>
       <p:sp>
         <p:nvSpPr>
-          <p:cNvPr id="6" name="TextBox 5"/>
+          <p:cNvPr id="7" name="TextBox 6"/>
           <p:cNvSpPr txBox="1"/>
           <p:nvPr/>
         </p:nvSpPr>
         <p:spPr>
           <a:xfrm>
             <a:off x="1097280" y="3429000"/>
-            <a:ext cx="8229600" cy="1097280"/>
+            <a:ext cx="8686800" cy="1097280"/>
           </a:xfrm>
           <a:prstGeom prst="rect">
             <a:avLst/>
@@ -3321,7 +3347,7 @@
       </p:sp>
       <p:sp>
         <p:nvSpPr>
-          <p:cNvPr id="7" name="TextBox 6"/>
+          <p:cNvPr id="8" name="TextBox 7"/>
           <p:cNvSpPr txBox="1"/>
           <p:nvPr/>
         </p:nvSpPr>
@@ -3364,74 +3390,6 @@
           </a:p>
         </p:txBody>
       </p:sp>
-      <p:sp>
-        <p:nvSpPr>
-          <p:cNvPr id="8" name="Oval 7"/>
-          <p:cNvSpPr/>
-          <p:nvPr/>
-        </p:nvSpPr>
-        <p:spPr>
-          <a:xfrm>
-            <a:off x="8738006" y="645566"/>
-            <a:ext cx="2457907" cy="2457907"/>
-          </a:xfrm>
-          <a:prstGeom prst="ellipse">
-            <a:avLst/>
-          </a:prstGeom>
-          <a:solidFill>
-            <a:srgbClr val="2A315C"/>
-          </a:solidFill>
-          <a:ln>
-            <a:noFill/>
-          </a:ln>
-          <a:effectLst/>
-        </p:spPr>
-        <p:style>
-          <a:lnRef idx="1">
-            <a:schemeClr val="accent1"/>
-          </a:lnRef>
-          <a:fillRef idx="3">
-            <a:schemeClr val="accent1"/>
-          </a:fillRef>
-          <a:effectRef idx="2">
-            <a:schemeClr val="accent1"/>
-          </a:effectRef>
-          <a:fontRef idx="minor">
-            <a:schemeClr val="lt1"/>
-          </a:fontRef>
-        </p:style>
-        <p:txBody>
-          <a:bodyPr rtlCol="0" anchor="ctr"/>
-          <a:lstStyle/>
-          <a:p>
-            <a:pPr algn="ctr"/>
-          </a:p>
-        </p:txBody>
-      </p:sp>
-      <p:pic>
-        <p:nvPicPr>
-          <p:cNvPr id="9" name="Picture 8" descr="1F4E3.png"/>
-          <p:cNvPicPr>
-            <a:picLocks noChangeAspect="1"/>
-          </p:cNvPicPr>
-          <p:nvPr/>
-        </p:nvPicPr>
-        <p:blipFill>
-          <a:blip r:embed="rId2"/>
-          <a:stretch>
-            <a:fillRect/>
-          </a:stretch>
-        </p:blipFill>
-        <p:spPr>
-          <a:xfrm>
-            <a:off x="9006840" y="914399"/>
-            <a:ext cx="1920240" cy="1920240"/>
-          </a:xfrm>
-          <a:prstGeom prst="rect">
-            <a:avLst/>
-          </a:prstGeom>
-        </p:spPr>
-      </p:pic>
     </p:spTree>
   </p:cSld>
   <p:clrMapOvr>
@@ -3450,9 +3408,33 @@
         <p:nvPr/>
       </p:nvGrpSpPr>
       <p:grpSpPr/>
-      <p:sp>
-        <p:nvSpPr>
-          <p:cNvPr id="2" name="Rectangle 1"/>
+      <p:pic>
+        <p:nvPicPr>
+          <p:cNvPr id="2" name="Picture 1" descr="s2.jpg"/>
+          <p:cNvPicPr>
+            <a:picLocks noChangeAspect="1"/>
+          </p:cNvPicPr>
+          <p:nvPr/>
+        </p:nvPicPr>
+        <p:blipFill>
+          <a:blip r:embed="rId2"/>
+          <a:stretch>
+            <a:fillRect/>
+          </a:stretch>
+        </p:blipFill>
+        <p:spPr>
+          <a:xfrm>
+            <a:off x="0" y="-1123489"/>
+            <a:ext cx="12191695" cy="9104979"/>
+          </a:xfrm>
+          <a:prstGeom prst="rect">
+            <a:avLst/>
+          </a:prstGeom>
+        </p:spPr>
+      </p:pic>
+      <p:sp>
+        <p:nvSpPr>
+          <p:cNvPr id="3" name="Rectangle 2"/>
           <p:cNvSpPr/>
           <p:nvPr/>
         </p:nvSpPr>
@@ -3465,7 +3447,9 @@
             <a:avLst/>
           </a:prstGeom>
           <a:solidFill>
-            <a:srgbClr val="FFFFFF"/>
+            <a:srgbClr val="161B3A">
+              <a:alpha val="72000"/>
+            </a:srgbClr>
           </a:solidFill>
           <a:ln>
             <a:noFill/>
@@ -3496,7 +3480,7 @@
       </p:sp>
       <p:sp>
         <p:nvSpPr>
-          <p:cNvPr id="3" name="Rectangle 2"/>
+          <p:cNvPr id="4" name="Rectangle 3"/>
           <p:cNvSpPr/>
           <p:nvPr/>
         </p:nvSpPr>
@@ -3540,7 +3524,7 @@
       </p:sp>
       <p:sp>
         <p:nvSpPr>
-          <p:cNvPr id="4" name="TextBox 3"/>
+          <p:cNvPr id="5" name="TextBox 4"/>
           <p:cNvSpPr txBox="1"/>
           <p:nvPr/>
         </p:nvSpPr>
@@ -3585,7 +3569,7 @@
       </p:sp>
       <p:sp>
         <p:nvSpPr>
-          <p:cNvPr id="5" name="TextBox 4"/>
+          <p:cNvPr id="6" name="TextBox 5"/>
           <p:cNvSpPr txBox="1"/>
           <p:nvPr/>
         </p:nvSpPr>
@@ -3619,7 +3603,7 @@
             <a:r>
               <a:rPr sz="4000" b="1">
                 <a:solidFill>
-                  <a:srgbClr val="161B3A"/>
+                  <a:srgbClr val="FFFFFF"/>
                 </a:solidFill>
                 <a:latin typeface="Verdana"/>
               </a:rPr>
@@ -3630,7 +3614,7 @@
       </p:sp>
       <p:sp>
         <p:nvSpPr>
-          <p:cNvPr id="6" name="TextBox 5"/>
+          <p:cNvPr id="7" name="TextBox 6"/>
           <p:cNvSpPr txBox="1"/>
           <p:nvPr/>
         </p:nvSpPr>
@@ -3664,7 +3648,7 @@
             <a:r>
               <a:rPr sz="1700" b="0">
                 <a:solidFill>
-                  <a:srgbClr val="5A607A"/>
+                  <a:srgbClr val="C9CDDE"/>
                 </a:solidFill>
                 <a:latin typeface="Verdana"/>
               </a:rPr>
@@ -3686,7 +3670,7 @@
             <a:r>
               <a:rPr sz="2100" b="1">
                 <a:solidFill>
-                  <a:srgbClr val="2A315C"/>
+                  <a:srgbClr val="FFFFFF"/>
                 </a:solidFill>
                 <a:latin typeface="Verdana"/>
               </a:rPr>
@@ -3708,7 +3692,7 @@
             <a:r>
               <a:rPr sz="2100" b="1">
                 <a:solidFill>
-                  <a:srgbClr val="2A315C"/>
+                  <a:srgbClr val="FFFFFF"/>
                 </a:solidFill>
                 <a:latin typeface="Verdana"/>
               </a:rPr>
@@ -3730,7 +3714,7 @@
             <a:r>
               <a:rPr sz="2100" b="1">
                 <a:solidFill>
-                  <a:srgbClr val="2A315C"/>
+                  <a:srgbClr val="FFFFFF"/>
                 </a:solidFill>
                 <a:latin typeface="Verdana"/>
               </a:rPr>
@@ -3741,7 +3725,7 @@
       </p:sp>
       <p:sp>
         <p:nvSpPr>
-          <p:cNvPr id="7" name="Rectangle 6"/>
+          <p:cNvPr id="8" name="Rectangle 7"/>
           <p:cNvSpPr/>
           <p:nvPr/>
         </p:nvSpPr>
@@ -3785,7 +3769,7 @@
       </p:sp>
       <p:sp>
         <p:nvSpPr>
-          <p:cNvPr id="8" name="Rectangle 7"/>
+          <p:cNvPr id="9" name="Rectangle 8"/>
           <p:cNvSpPr/>
           <p:nvPr/>
         </p:nvSpPr>
@@ -3829,7 +3813,7 @@
       </p:sp>
       <p:sp>
         <p:nvSpPr>
-          <p:cNvPr id="9" name="TextBox 8"/>
+          <p:cNvPr id="10" name="TextBox 9"/>
           <p:cNvSpPr txBox="1"/>
           <p:nvPr/>
         </p:nvSpPr>
@@ -3896,75 +3880,7 @@
       </p:sp>
       <p:sp>
         <p:nvSpPr>
-          <p:cNvPr id="10" name="Oval 9"/>
-          <p:cNvSpPr/>
-          <p:nvPr/>
-        </p:nvSpPr>
-        <p:spPr>
-          <a:xfrm>
-            <a:off x="9769449" y="3002889"/>
-            <a:ext cx="2223820" cy="2223820"/>
-          </a:xfrm>
-          <a:prstGeom prst="ellipse">
-            <a:avLst/>
-          </a:prstGeom>
-          <a:solidFill>
-            <a:srgbClr val="FCE7CF"/>
-          </a:solidFill>
-          <a:ln>
-            <a:noFill/>
-          </a:ln>
-          <a:effectLst/>
-        </p:spPr>
-        <p:style>
-          <a:lnRef idx="1">
-            <a:schemeClr val="accent1"/>
-          </a:lnRef>
-          <a:fillRef idx="3">
-            <a:schemeClr val="accent1"/>
-          </a:fillRef>
-          <a:effectRef idx="2">
-            <a:schemeClr val="accent1"/>
-          </a:effectRef>
-          <a:fontRef idx="minor">
-            <a:schemeClr val="lt1"/>
-          </a:fontRef>
-        </p:style>
-        <p:txBody>
-          <a:bodyPr rtlCol="0" anchor="ctr"/>
-          <a:lstStyle/>
-          <a:p>
-            <a:pPr algn="ctr"/>
-          </a:p>
-        </p:txBody>
-      </p:sp>
-      <p:pic>
-        <p:nvPicPr>
-          <p:cNvPr id="11" name="Picture 10" descr="1F3EB.png"/>
-          <p:cNvPicPr>
-            <a:picLocks noChangeAspect="1"/>
-          </p:cNvPicPr>
-          <p:nvPr/>
-        </p:nvPicPr>
-        <p:blipFill>
-          <a:blip r:embed="rId2"/>
-          <a:stretch>
-            <a:fillRect/>
-          </a:stretch>
-        </p:blipFill>
-        <p:spPr>
-          <a:xfrm>
-            <a:off x="10012680" y="3246120"/>
-            <a:ext cx="1737360" cy="1737360"/>
-          </a:xfrm>
-          <a:prstGeom prst="rect">
-            <a:avLst/>
-          </a:prstGeom>
-        </p:spPr>
-      </p:pic>
-      <p:sp>
-        <p:nvSpPr>
-          <p:cNvPr id="12" name="TextBox 11"/>
+          <p:cNvPr id="11" name="TextBox 10"/>
           <p:cNvSpPr txBox="1"/>
           <p:nvPr/>
         </p:nvSpPr>
@@ -3998,7 +3914,7 @@
             <a:r>
               <a:rPr sz="1100" b="0">
                 <a:solidFill>
-                  <a:srgbClr val="5A607A"/>
+                  <a:srgbClr val="C9CDDE"/>
                 </a:solidFill>
                 <a:latin typeface="Verdana"/>
               </a:rPr>
@@ -4009,7 +3925,7 @@
       </p:sp>
       <p:sp>
         <p:nvSpPr>
-          <p:cNvPr id="13" name="TextBox 12"/>
+          <p:cNvPr id="12" name="TextBox 11"/>
           <p:cNvSpPr txBox="1"/>
           <p:nvPr/>
         </p:nvSpPr>
@@ -4043,7 +3959,7 @@
             <a:r>
               <a:rPr sz="1100" b="1">
                 <a:solidFill>
-                  <a:srgbClr val="5A607A"/>
+                  <a:srgbClr val="C9CDDE"/>
                 </a:solidFill>
                 <a:latin typeface="Verdana"/>
               </a:rPr>
@@ -4070,9 +3986,33 @@
         <p:nvPr/>
       </p:nvGrpSpPr>
       <p:grpSpPr/>
-      <p:sp>
-        <p:nvSpPr>
-          <p:cNvPr id="2" name="Rectangle 1"/>
+      <p:pic>
+        <p:nvPicPr>
+          <p:cNvPr id="2" name="Picture 1" descr="s3.jpg"/>
+          <p:cNvPicPr>
+            <a:picLocks noChangeAspect="1"/>
+          </p:cNvPicPr>
+          <p:nvPr/>
+        </p:nvPicPr>
+        <p:blipFill>
+          <a:blip r:embed="rId2"/>
+          <a:stretch>
+            <a:fillRect/>
+          </a:stretch>
+        </p:blipFill>
+        <p:spPr>
+          <a:xfrm>
+            <a:off x="0" y="-635821"/>
+            <a:ext cx="12191695" cy="8129643"/>
+          </a:xfrm>
+          <a:prstGeom prst="rect">
+            <a:avLst/>
+          </a:prstGeom>
+        </p:spPr>
+      </p:pic>
+      <p:sp>
+        <p:nvSpPr>
+          <p:cNvPr id="3" name="Rectangle 2"/>
           <p:cNvSpPr/>
           <p:nvPr/>
         </p:nvSpPr>
@@ -4085,7 +4025,9 @@
             <a:avLst/>
           </a:prstGeom>
           <a:solidFill>
-            <a:srgbClr val="FFFFFF"/>
+            <a:srgbClr val="161B3A">
+              <a:alpha val="76000"/>
+            </a:srgbClr>
           </a:solidFill>
           <a:ln>
             <a:noFill/>
@@ -4116,7 +4058,7 @@
       </p:sp>
       <p:sp>
         <p:nvSpPr>
-          <p:cNvPr id="3" name="Rectangle 2"/>
+          <p:cNvPr id="4" name="Rectangle 3"/>
           <p:cNvSpPr/>
           <p:nvPr/>
         </p:nvSpPr>
@@ -4160,7 +4102,7 @@
       </p:sp>
       <p:sp>
         <p:nvSpPr>
-          <p:cNvPr id="4" name="TextBox 3"/>
+          <p:cNvPr id="5" name="TextBox 4"/>
           <p:cNvSpPr txBox="1"/>
           <p:nvPr/>
         </p:nvSpPr>
@@ -4205,7 +4147,7 @@
       </p:sp>
       <p:sp>
         <p:nvSpPr>
-          <p:cNvPr id="5" name="TextBox 4"/>
+          <p:cNvPr id="6" name="TextBox 5"/>
           <p:cNvSpPr txBox="1"/>
           <p:nvPr/>
         </p:nvSpPr>
@@ -4239,7 +4181,7 @@
             <a:r>
               <a:rPr sz="4000" b="1">
                 <a:solidFill>
-                  <a:srgbClr val="161B3A"/>
+                  <a:srgbClr val="FFFFFF"/>
                 </a:solidFill>
                 <a:latin typeface="Verdana"/>
               </a:rPr>
@@ -4250,7 +4192,7 @@
       </p:sp>
       <p:sp>
         <p:nvSpPr>
-          <p:cNvPr id="6" name="Rectangle 5"/>
+          <p:cNvPr id="7" name="Rectangle 6"/>
           <p:cNvSpPr/>
           <p:nvPr/>
         </p:nvSpPr>
@@ -4294,7 +4236,7 @@
       </p:sp>
       <p:sp>
         <p:nvSpPr>
-          <p:cNvPr id="7" name="TextBox 6"/>
+          <p:cNvPr id="8" name="TextBox 7"/>
           <p:cNvSpPr txBox="1"/>
           <p:nvPr/>
         </p:nvSpPr>
@@ -4339,7 +4281,7 @@
       </p:sp>
       <p:sp>
         <p:nvSpPr>
-          <p:cNvPr id="8" name="TextBox 7"/>
+          <p:cNvPr id="9" name="TextBox 8"/>
           <p:cNvSpPr txBox="1"/>
           <p:nvPr/>
         </p:nvSpPr>
@@ -4384,7 +4326,7 @@
       </p:sp>
       <p:sp>
         <p:nvSpPr>
-          <p:cNvPr id="9" name="Rectangle 8"/>
+          <p:cNvPr id="10" name="Rectangle 9"/>
           <p:cNvSpPr/>
           <p:nvPr/>
         </p:nvSpPr>
@@ -4428,7 +4370,7 @@
       </p:sp>
       <p:sp>
         <p:nvSpPr>
-          <p:cNvPr id="10" name="TextBox 9"/>
+          <p:cNvPr id="11" name="TextBox 10"/>
           <p:cNvSpPr txBox="1"/>
           <p:nvPr/>
         </p:nvSpPr>
@@ -4473,7 +4415,7 @@
       </p:sp>
       <p:sp>
         <p:nvSpPr>
-          <p:cNvPr id="11" name="TextBox 10"/>
+          <p:cNvPr id="12" name="TextBox 11"/>
           <p:cNvSpPr txBox="1"/>
           <p:nvPr/>
         </p:nvSpPr>
@@ -4518,7 +4460,7 @@
       </p:sp>
       <p:sp>
         <p:nvSpPr>
-          <p:cNvPr id="12" name="Rectangle 11"/>
+          <p:cNvPr id="13" name="Rectangle 12"/>
           <p:cNvSpPr/>
           <p:nvPr/>
         </p:nvSpPr>
@@ -4562,7 +4504,7 @@
       </p:sp>
       <p:sp>
         <p:nvSpPr>
-          <p:cNvPr id="13" name="TextBox 12"/>
+          <p:cNvPr id="14" name="TextBox 13"/>
           <p:cNvSpPr txBox="1"/>
           <p:nvPr/>
         </p:nvSpPr>
@@ -4607,7 +4549,7 @@
       </p:sp>
       <p:sp>
         <p:nvSpPr>
-          <p:cNvPr id="14" name="TextBox 13"/>
+          <p:cNvPr id="15" name="TextBox 14"/>
           <p:cNvSpPr txBox="1"/>
           <p:nvPr/>
         </p:nvSpPr>
@@ -4652,7 +4594,7 @@
       </p:sp>
       <p:sp>
         <p:nvSpPr>
-          <p:cNvPr id="15" name="TextBox 14"/>
+          <p:cNvPr id="16" name="TextBox 15"/>
           <p:cNvSpPr txBox="1"/>
           <p:nvPr/>
         </p:nvSpPr>
@@ -4686,7 +4628,7 @@
             <a:r>
               <a:rPr sz="2400" b="1">
                 <a:solidFill>
-                  <a:srgbClr val="161B3A"/>
+                  <a:srgbClr val="FFFFFF"/>
                 </a:solidFill>
                 <a:latin typeface="Verdana"/>
               </a:rPr>
@@ -4708,7 +4650,7 @@
             <a:r>
               <a:rPr sz="1600" b="0">
                 <a:solidFill>
-                  <a:srgbClr val="5A607A"/>
+                  <a:srgbClr val="C9CDDE"/>
                 </a:solidFill>
                 <a:latin typeface="Verdana"/>
               </a:rPr>
@@ -4719,75 +4661,7 @@
       </p:sp>
       <p:sp>
         <p:nvSpPr>
-          <p:cNvPr id="16" name="Oval 15"/>
-          <p:cNvSpPr/>
-          <p:nvPr/>
-        </p:nvSpPr>
-        <p:spPr>
-          <a:xfrm>
-            <a:off x="9827971" y="4021531"/>
-            <a:ext cx="2106777" cy="2106777"/>
-          </a:xfrm>
-          <a:prstGeom prst="ellipse">
-            <a:avLst/>
-          </a:prstGeom>
-          <a:solidFill>
-            <a:srgbClr val="FCE7CF"/>
-          </a:solidFill>
-          <a:ln>
-            <a:noFill/>
-          </a:ln>
-          <a:effectLst/>
-        </p:spPr>
-        <p:style>
-          <a:lnRef idx="1">
-            <a:schemeClr val="accent1"/>
-          </a:lnRef>
-          <a:fillRef idx="3">
-            <a:schemeClr val="accent1"/>
-          </a:fillRef>
-          <a:effectRef idx="2">
-            <a:schemeClr val="accent1"/>
-          </a:effectRef>
-          <a:fontRef idx="minor">
-            <a:schemeClr val="lt1"/>
-          </a:fontRef>
-        </p:style>
-        <p:txBody>
-          <a:bodyPr rtlCol="0" anchor="ctr"/>
-          <a:lstStyle/>
-          <a:p>
-            <a:pPr algn="ctr"/>
-          </a:p>
-        </p:txBody>
-      </p:sp>
-      <p:pic>
-        <p:nvPicPr>
-          <p:cNvPr id="17" name="Picture 16" descr="1F4AC.png"/>
-          <p:cNvPicPr>
-            <a:picLocks noChangeAspect="1"/>
-          </p:cNvPicPr>
-          <p:nvPr/>
-        </p:nvPicPr>
-        <p:blipFill>
-          <a:blip r:embed="rId2"/>
-          <a:stretch>
-            <a:fillRect/>
-          </a:stretch>
-        </p:blipFill>
-        <p:spPr>
-          <a:xfrm>
-            <a:off x="10058400" y="4251959"/>
-            <a:ext cx="1645920" cy="1645920"/>
-          </a:xfrm>
-          <a:prstGeom prst="rect">
-            <a:avLst/>
-          </a:prstGeom>
-        </p:spPr>
-      </p:pic>
-      <p:sp>
-        <p:nvSpPr>
-          <p:cNvPr id="18" name="TextBox 17"/>
+          <p:cNvPr id="17" name="TextBox 16"/>
           <p:cNvSpPr txBox="1"/>
           <p:nvPr/>
         </p:nvSpPr>
@@ -4821,7 +4695,7 @@
             <a:r>
               <a:rPr sz="1100" b="0">
                 <a:solidFill>
-                  <a:srgbClr val="5A607A"/>
+                  <a:srgbClr val="C9CDDE"/>
                 </a:solidFill>
                 <a:latin typeface="Verdana"/>
               </a:rPr>
@@ -4832,7 +4706,7 @@
       </p:sp>
       <p:sp>
         <p:nvSpPr>
-          <p:cNvPr id="19" name="TextBox 18"/>
+          <p:cNvPr id="18" name="TextBox 17"/>
           <p:cNvSpPr txBox="1"/>
           <p:nvPr/>
         </p:nvSpPr>
@@ -4866,7 +4740,7 @@
             <a:r>
               <a:rPr sz="1100" b="1">
                 <a:solidFill>
-                  <a:srgbClr val="5A607A"/>
+                  <a:srgbClr val="C9CDDE"/>
                 </a:solidFill>
                 <a:latin typeface="Verdana"/>
               </a:rPr>
@@ -4893,9 +4767,33 @@
         <p:nvPr/>
       </p:nvGrpSpPr>
       <p:grpSpPr/>
-      <p:sp>
-        <p:nvSpPr>
-          <p:cNvPr id="2" name="Rectangle 1"/>
+      <p:pic>
+        <p:nvPicPr>
+          <p:cNvPr id="2" name="Picture 1" descr="s4.jpg"/>
+          <p:cNvPicPr>
+            <a:picLocks noChangeAspect="1"/>
+          </p:cNvPicPr>
+          <p:nvPr/>
+        </p:nvPicPr>
+        <p:blipFill>
+          <a:blip r:embed="rId2"/>
+          <a:stretch>
+            <a:fillRect/>
+          </a:stretch>
+        </p:blipFill>
+        <p:spPr>
+          <a:xfrm>
+            <a:off x="-7550" y="0"/>
+            <a:ext cx="12206796" cy="6858000"/>
+          </a:xfrm>
+          <a:prstGeom prst="rect">
+            <a:avLst/>
+          </a:prstGeom>
+        </p:spPr>
+      </p:pic>
+      <p:sp>
+        <p:nvSpPr>
+          <p:cNvPr id="3" name="Rectangle 2"/>
           <p:cNvSpPr/>
           <p:nvPr/>
         </p:nvSpPr>
@@ -4908,7 +4806,9 @@
             <a:avLst/>
           </a:prstGeom>
           <a:solidFill>
-            <a:srgbClr val="FFFFFF"/>
+            <a:srgbClr val="161B3A">
+              <a:alpha val="72000"/>
+            </a:srgbClr>
           </a:solidFill>
           <a:ln>
             <a:noFill/>
@@ -4939,7 +4839,7 @@
       </p:sp>
       <p:sp>
         <p:nvSpPr>
-          <p:cNvPr id="3" name="Rectangle 2"/>
+          <p:cNvPr id="4" name="Rectangle 3"/>
           <p:cNvSpPr/>
           <p:nvPr/>
         </p:nvSpPr>
@@ -4983,7 +4883,7 @@
       </p:sp>
       <p:sp>
         <p:nvSpPr>
-          <p:cNvPr id="4" name="Rectangle 3"/>
+          <p:cNvPr id="5" name="Rectangle 4"/>
           <p:cNvSpPr/>
           <p:nvPr/>
         </p:nvSpPr>
@@ -5027,7 +4927,7 @@
       </p:sp>
       <p:sp>
         <p:nvSpPr>
-          <p:cNvPr id="5" name="TextBox 4"/>
+          <p:cNvPr id="6" name="TextBox 5"/>
           <p:cNvSpPr txBox="1"/>
           <p:nvPr/>
         </p:nvSpPr>
@@ -5072,7 +4972,7 @@
       </p:sp>
       <p:sp>
         <p:nvSpPr>
-          <p:cNvPr id="6" name="TextBox 5"/>
+          <p:cNvPr id="7" name="TextBox 6"/>
           <p:cNvSpPr txBox="1"/>
           <p:nvPr/>
         </p:nvSpPr>
@@ -5106,7 +5006,7 @@
             <a:r>
               <a:rPr sz="3800" b="1">
                 <a:solidFill>
-                  <a:srgbClr val="161B3A"/>
+                  <a:srgbClr val="FFFFFF"/>
                 </a:solidFill>
                 <a:latin typeface="Verdana"/>
               </a:rPr>
@@ -5117,7 +5017,7 @@
       </p:sp>
       <p:sp>
         <p:nvSpPr>
-          <p:cNvPr id="7" name="TextBox 6"/>
+          <p:cNvPr id="8" name="TextBox 7"/>
           <p:cNvSpPr txBox="1"/>
           <p:nvPr/>
         </p:nvSpPr>
@@ -5151,7 +5051,7 @@
             <a:r>
               <a:rPr sz="2100" b="0">
                 <a:solidFill>
-                  <a:srgbClr val="5A607A"/>
+                  <a:srgbClr val="C9CDDE"/>
                 </a:solidFill>
                 <a:latin typeface="Verdana"/>
               </a:rPr>
@@ -5184,75 +5084,7 @@
       </p:sp>
       <p:sp>
         <p:nvSpPr>
-          <p:cNvPr id="8" name="Oval 7"/>
-          <p:cNvSpPr/>
-          <p:nvPr/>
-        </p:nvSpPr>
-        <p:spPr>
-          <a:xfrm>
-            <a:off x="9769449" y="3460089"/>
-            <a:ext cx="2223820" cy="2223820"/>
-          </a:xfrm>
-          <a:prstGeom prst="ellipse">
-            <a:avLst/>
-          </a:prstGeom>
-          <a:solidFill>
-            <a:srgbClr val="FCE7CF"/>
-          </a:solidFill>
-          <a:ln>
-            <a:noFill/>
-          </a:ln>
-          <a:effectLst/>
-        </p:spPr>
-        <p:style>
-          <a:lnRef idx="1">
-            <a:schemeClr val="accent1"/>
-          </a:lnRef>
-          <a:fillRef idx="3">
-            <a:schemeClr val="accent1"/>
-          </a:fillRef>
-          <a:effectRef idx="2">
-            <a:schemeClr val="accent1"/>
-          </a:effectRef>
-          <a:fontRef idx="minor">
-            <a:schemeClr val="lt1"/>
-          </a:fontRef>
-        </p:style>
-        <p:txBody>
-          <a:bodyPr rtlCol="0" anchor="ctr"/>
-          <a:lstStyle/>
-          <a:p>
-            <a:pPr algn="ctr"/>
-          </a:p>
-        </p:txBody>
-      </p:sp>
-      <p:pic>
-        <p:nvPicPr>
-          <p:cNvPr id="9" name="Picture 8" descr="1F4DD.png"/>
-          <p:cNvPicPr>
-            <a:picLocks noChangeAspect="1"/>
-          </p:cNvPicPr>
-          <p:nvPr/>
-        </p:nvPicPr>
-        <p:blipFill>
-          <a:blip r:embed="rId2"/>
-          <a:stretch>
-            <a:fillRect/>
-          </a:stretch>
-        </p:blipFill>
-        <p:spPr>
-          <a:xfrm>
-            <a:off x="10012680" y="3703320"/>
-            <a:ext cx="1737360" cy="1737360"/>
-          </a:xfrm>
-          <a:prstGeom prst="rect">
-            <a:avLst/>
-          </a:prstGeom>
-        </p:spPr>
-      </p:pic>
-      <p:sp>
-        <p:nvSpPr>
-          <p:cNvPr id="10" name="TextBox 9"/>
+          <p:cNvPr id="9" name="TextBox 8"/>
           <p:cNvSpPr txBox="1"/>
           <p:nvPr/>
         </p:nvSpPr>
@@ -5286,7 +5118,7 @@
             <a:r>
               <a:rPr sz="1100" b="0">
                 <a:solidFill>
-                  <a:srgbClr val="5A607A"/>
+                  <a:srgbClr val="C9CDDE"/>
                 </a:solidFill>
                 <a:latin typeface="Verdana"/>
               </a:rPr>
@@ -5297,7 +5129,7 @@
       </p:sp>
       <p:sp>
         <p:nvSpPr>
-          <p:cNvPr id="11" name="TextBox 10"/>
+          <p:cNvPr id="10" name="TextBox 9"/>
           <p:cNvSpPr txBox="1"/>
           <p:nvPr/>
         </p:nvSpPr>
@@ -5331,7 +5163,7 @@
             <a:r>
               <a:rPr sz="1100" b="1">
                 <a:solidFill>
-                  <a:srgbClr val="5A607A"/>
+                  <a:srgbClr val="C9CDDE"/>
                 </a:solidFill>
                 <a:latin typeface="Verdana"/>
               </a:rPr>
@@ -5358,9 +5190,33 @@
         <p:nvPr/>
       </p:nvGrpSpPr>
       <p:grpSpPr/>
-      <p:sp>
-        <p:nvSpPr>
-          <p:cNvPr id="2" name="Rectangle 1"/>
+      <p:pic>
+        <p:nvPicPr>
+          <p:cNvPr id="2" name="Picture 1" descr="s5.jpg"/>
+          <p:cNvPicPr>
+            <a:picLocks noChangeAspect="1"/>
+          </p:cNvPicPr>
+          <p:nvPr/>
+        </p:nvPicPr>
+        <p:blipFill>
+          <a:blip r:embed="rId2"/>
+          <a:stretch>
+            <a:fillRect/>
+          </a:stretch>
+        </p:blipFill>
+        <p:spPr>
+          <a:xfrm>
+            <a:off x="-7550" y="0"/>
+            <a:ext cx="12206796" cy="6858000"/>
+          </a:xfrm>
+          <a:prstGeom prst="rect">
+            <a:avLst/>
+          </a:prstGeom>
+        </p:spPr>
+      </p:pic>
+      <p:sp>
+        <p:nvSpPr>
+          <p:cNvPr id="3" name="Rectangle 2"/>
           <p:cNvSpPr/>
           <p:nvPr/>
         </p:nvSpPr>
@@ -5373,7 +5229,9 @@
             <a:avLst/>
           </a:prstGeom>
           <a:solidFill>
-            <a:srgbClr val="FFFFFF"/>
+            <a:srgbClr val="161B3A">
+              <a:alpha val="66000"/>
+            </a:srgbClr>
           </a:solidFill>
           <a:ln>
             <a:noFill/>
@@ -5404,7 +5262,7 @@
       </p:sp>
       <p:sp>
         <p:nvSpPr>
-          <p:cNvPr id="3" name="Rectangle 2"/>
+          <p:cNvPr id="4" name="Rectangle 3"/>
           <p:cNvSpPr/>
           <p:nvPr/>
         </p:nvSpPr>
@@ -5448,7 +5306,7 @@
       </p:sp>
       <p:sp>
         <p:nvSpPr>
-          <p:cNvPr id="4" name="Rectangle 3"/>
+          <p:cNvPr id="5" name="Rectangle 4"/>
           <p:cNvSpPr/>
           <p:nvPr/>
         </p:nvSpPr>
@@ -5492,7 +5350,7 @@
       </p:sp>
       <p:sp>
         <p:nvSpPr>
-          <p:cNvPr id="5" name="TextBox 4"/>
+          <p:cNvPr id="6" name="TextBox 5"/>
           <p:cNvSpPr txBox="1"/>
           <p:nvPr/>
         </p:nvSpPr>
@@ -5537,7 +5395,7 @@
       </p:sp>
       <p:sp>
         <p:nvSpPr>
-          <p:cNvPr id="6" name="TextBox 5"/>
+          <p:cNvPr id="7" name="TextBox 6"/>
           <p:cNvSpPr txBox="1"/>
           <p:nvPr/>
         </p:nvSpPr>
@@ -5571,7 +5429,7 @@
             <a:r>
               <a:rPr sz="4000" b="1">
                 <a:solidFill>
-                  <a:srgbClr val="161B3A"/>
+                  <a:srgbClr val="FFFFFF"/>
                 </a:solidFill>
                 <a:latin typeface="Verdana"/>
               </a:rPr>
@@ -5582,7 +5440,7 @@
       </p:sp>
       <p:sp>
         <p:nvSpPr>
-          <p:cNvPr id="7" name="TextBox 6"/>
+          <p:cNvPr id="8" name="TextBox 7"/>
           <p:cNvSpPr txBox="1"/>
           <p:nvPr/>
         </p:nvSpPr>
@@ -5638,7 +5496,7 @@
             <a:r>
               <a:rPr sz="2000" b="0">
                 <a:solidFill>
-                  <a:srgbClr val="2A315C"/>
+                  <a:srgbClr val="FFFFFF"/>
                 </a:solidFill>
                 <a:latin typeface="Verdana"/>
               </a:rPr>
@@ -5660,7 +5518,7 @@
             <a:r>
               <a:rPr sz="2000" b="0">
                 <a:solidFill>
-                  <a:srgbClr val="2A315C"/>
+                  <a:srgbClr val="FFFFFF"/>
                 </a:solidFill>
                 <a:latin typeface="Verdana"/>
               </a:rPr>
@@ -5682,7 +5540,7 @@
             <a:r>
               <a:rPr sz="2000" b="0">
                 <a:solidFill>
-                  <a:srgbClr val="2A315C"/>
+                  <a:srgbClr val="FFFFFF"/>
                 </a:solidFill>
                 <a:latin typeface="Verdana"/>
               </a:rPr>
@@ -5693,7 +5551,7 @@
       </p:sp>
       <p:sp>
         <p:nvSpPr>
-          <p:cNvPr id="8" name="Rectangle 7"/>
+          <p:cNvPr id="9" name="Rectangle 8"/>
           <p:cNvSpPr/>
           <p:nvPr/>
         </p:nvSpPr>
@@ -5737,7 +5595,7 @@
       </p:sp>
       <p:sp>
         <p:nvSpPr>
-          <p:cNvPr id="9" name="TextBox 8"/>
+          <p:cNvPr id="10" name="TextBox 9"/>
           <p:cNvSpPr txBox="1"/>
           <p:nvPr/>
         </p:nvSpPr>
@@ -5848,75 +5706,7 @@
       </p:sp>
       <p:sp>
         <p:nvSpPr>
-          <p:cNvPr id="10" name="Oval 9"/>
-          <p:cNvSpPr/>
-          <p:nvPr/>
-        </p:nvSpPr>
-        <p:spPr>
-          <a:xfrm>
-            <a:off x="9769449" y="2545689"/>
-            <a:ext cx="2223820" cy="2223820"/>
-          </a:xfrm>
-          <a:prstGeom prst="ellipse">
-            <a:avLst/>
-          </a:prstGeom>
-          <a:solidFill>
-            <a:srgbClr val="FCE7CF"/>
-          </a:solidFill>
-          <a:ln>
-            <a:noFill/>
-          </a:ln>
-          <a:effectLst/>
-        </p:spPr>
-        <p:style>
-          <a:lnRef idx="1">
-            <a:schemeClr val="accent1"/>
-          </a:lnRef>
-          <a:fillRef idx="3">
-            <a:schemeClr val="accent1"/>
-          </a:fillRef>
-          <a:effectRef idx="2">
-            <a:schemeClr val="accent1"/>
-          </a:effectRef>
-          <a:fontRef idx="minor">
-            <a:schemeClr val="lt1"/>
-          </a:fontRef>
-        </p:style>
-        <p:txBody>
-          <a:bodyPr rtlCol="0" anchor="ctr"/>
-          <a:lstStyle/>
-          <a:p>
-            <a:pPr algn="ctr"/>
-          </a:p>
-        </p:txBody>
-      </p:sp>
-      <p:pic>
-        <p:nvPicPr>
-          <p:cNvPr id="11" name="Picture 10" descr="1F4A1.png"/>
-          <p:cNvPicPr>
-            <a:picLocks noChangeAspect="1"/>
-          </p:cNvPicPr>
-          <p:nvPr/>
-        </p:nvPicPr>
-        <p:blipFill>
-          <a:blip r:embed="rId2"/>
-          <a:stretch>
-            <a:fillRect/>
-          </a:stretch>
-        </p:blipFill>
-        <p:spPr>
-          <a:xfrm>
-            <a:off x="10012680" y="2788920"/>
-            <a:ext cx="1737360" cy="1737360"/>
-          </a:xfrm>
-          <a:prstGeom prst="rect">
-            <a:avLst/>
-          </a:prstGeom>
-        </p:spPr>
-      </p:pic>
-      <p:sp>
-        <p:nvSpPr>
-          <p:cNvPr id="12" name="TextBox 11"/>
+          <p:cNvPr id="11" name="TextBox 10"/>
           <p:cNvSpPr txBox="1"/>
           <p:nvPr/>
         </p:nvSpPr>
@@ -5950,7 +5740,7 @@
             <a:r>
               <a:rPr sz="1100" b="0">
                 <a:solidFill>
-                  <a:srgbClr val="5A607A"/>
+                  <a:srgbClr val="C9CDDE"/>
                 </a:solidFill>
                 <a:latin typeface="Verdana"/>
               </a:rPr>
@@ -5961,7 +5751,7 @@
       </p:sp>
       <p:sp>
         <p:nvSpPr>
-          <p:cNvPr id="13" name="TextBox 12"/>
+          <p:cNvPr id="12" name="TextBox 11"/>
           <p:cNvSpPr txBox="1"/>
           <p:nvPr/>
         </p:nvSpPr>
@@ -5995,7 +5785,7 @@
             <a:r>
               <a:rPr sz="1100" b="1">
                 <a:solidFill>
-                  <a:srgbClr val="5A607A"/>
+                  <a:srgbClr val="C9CDDE"/>
                 </a:solidFill>
                 <a:latin typeface="Verdana"/>
               </a:rPr>
@@ -6022,9 +5812,33 @@
         <p:nvPr/>
       </p:nvGrpSpPr>
       <p:grpSpPr/>
-      <p:sp>
-        <p:nvSpPr>
-          <p:cNvPr id="2" name="Rectangle 1"/>
+      <p:pic>
+        <p:nvPicPr>
+          <p:cNvPr id="2" name="Picture 1" descr="s6.jpg"/>
+          <p:cNvPicPr>
+            <a:picLocks noChangeAspect="1"/>
+          </p:cNvPicPr>
+          <p:nvPr/>
+        </p:nvPicPr>
+        <p:blipFill>
+          <a:blip r:embed="rId2"/>
+          <a:stretch>
+            <a:fillRect/>
+          </a:stretch>
+        </p:blipFill>
+        <p:spPr>
+          <a:xfrm>
+            <a:off x="0" y="-1007114"/>
+            <a:ext cx="12191695" cy="8872228"/>
+          </a:xfrm>
+          <a:prstGeom prst="rect">
+            <a:avLst/>
+          </a:prstGeom>
+        </p:spPr>
+      </p:pic>
+      <p:sp>
+        <p:nvSpPr>
+          <p:cNvPr id="3" name="Rectangle 2"/>
           <p:cNvSpPr/>
           <p:nvPr/>
         </p:nvSpPr>
@@ -6037,7 +5851,9 @@
             <a:avLst/>
           </a:prstGeom>
           <a:solidFill>
-            <a:srgbClr val="FFFFFF"/>
+            <a:srgbClr val="161B3A">
+              <a:alpha val="72000"/>
+            </a:srgbClr>
           </a:solidFill>
           <a:ln>
             <a:noFill/>
@@ -6068,7 +5884,7 @@
       </p:sp>
       <p:sp>
         <p:nvSpPr>
-          <p:cNvPr id="3" name="Rectangle 2"/>
+          <p:cNvPr id="4" name="Rectangle 3"/>
           <p:cNvSpPr/>
           <p:nvPr/>
         </p:nvSpPr>
@@ -6112,7 +5928,7 @@
       </p:sp>
       <p:sp>
         <p:nvSpPr>
-          <p:cNvPr id="4" name="TextBox 3"/>
+          <p:cNvPr id="5" name="TextBox 4"/>
           <p:cNvSpPr txBox="1"/>
           <p:nvPr/>
         </p:nvSpPr>
@@ -6157,7 +5973,7 @@
       </p:sp>
       <p:sp>
         <p:nvSpPr>
-          <p:cNvPr id="5" name="TextBox 4"/>
+          <p:cNvPr id="6" name="TextBox 5"/>
           <p:cNvSpPr txBox="1"/>
           <p:nvPr/>
         </p:nvSpPr>
@@ -6202,7 +6018,7 @@
       </p:sp>
       <p:sp>
         <p:nvSpPr>
-          <p:cNvPr id="6" name="TextBox 5"/>
+          <p:cNvPr id="7" name="TextBox 6"/>
           <p:cNvSpPr txBox="1"/>
           <p:nvPr/>
         </p:nvSpPr>
@@ -6236,7 +6052,7 @@
             <a:r>
               <a:rPr sz="2600" b="1">
                 <a:solidFill>
-                  <a:srgbClr val="161B3A"/>
+                  <a:srgbClr val="FFFFFF"/>
                 </a:solidFill>
                 <a:latin typeface="Verdana"/>
               </a:rPr>
@@ -6258,7 +6074,7 @@
             <a:r>
               <a:rPr sz="2100" b="0">
                 <a:solidFill>
-                  <a:srgbClr val="5A607A"/>
+                  <a:srgbClr val="C9CDDE"/>
                 </a:solidFill>
                 <a:latin typeface="Verdana"/>
               </a:rPr>
@@ -6269,75 +6085,7 @@
       </p:sp>
       <p:sp>
         <p:nvSpPr>
-          <p:cNvPr id="7" name="Oval 6"/>
-          <p:cNvSpPr/>
-          <p:nvPr/>
-        </p:nvSpPr>
-        <p:spPr>
-          <a:xfrm>
-            <a:off x="9769449" y="1265529"/>
-            <a:ext cx="2223820" cy="2223820"/>
-          </a:xfrm>
-          <a:prstGeom prst="ellipse">
-            <a:avLst/>
-          </a:prstGeom>
-          <a:solidFill>
-            <a:srgbClr val="FCE7CF"/>
-          </a:solidFill>
-          <a:ln>
-            <a:noFill/>
-          </a:ln>
-          <a:effectLst/>
-        </p:spPr>
-        <p:style>
-          <a:lnRef idx="1">
-            <a:schemeClr val="accent1"/>
-          </a:lnRef>
-          <a:fillRef idx="3">
-            <a:schemeClr val="accent1"/>
-          </a:fillRef>
-          <a:effectRef idx="2">
-            <a:schemeClr val="accent1"/>
-          </a:effectRef>
-          <a:fontRef idx="minor">
-            <a:schemeClr val="lt1"/>
-          </a:fontRef>
-        </p:style>
-        <p:txBody>
-          <a:bodyPr rtlCol="0" anchor="ctr"/>
-          <a:lstStyle/>
-          <a:p>
-            <a:pPr algn="ctr"/>
-          </a:p>
-        </p:txBody>
-      </p:sp>
-      <p:pic>
-        <p:nvPicPr>
-          <p:cNvPr id="8" name="Picture 7" descr="1F64B.png"/>
-          <p:cNvPicPr>
-            <a:picLocks noChangeAspect="1"/>
-          </p:cNvPicPr>
-          <p:nvPr/>
-        </p:nvPicPr>
-        <p:blipFill>
-          <a:blip r:embed="rId2"/>
-          <a:stretch>
-            <a:fillRect/>
-          </a:stretch>
-        </p:blipFill>
-        <p:spPr>
-          <a:xfrm>
-            <a:off x="10012680" y="1508760"/>
-            <a:ext cx="1737360" cy="1737360"/>
-          </a:xfrm>
-          <a:prstGeom prst="rect">
-            <a:avLst/>
-          </a:prstGeom>
-        </p:spPr>
-      </p:pic>
-      <p:sp>
-        <p:nvSpPr>
-          <p:cNvPr id="9" name="TextBox 8"/>
+          <p:cNvPr id="8" name="TextBox 7"/>
           <p:cNvSpPr txBox="1"/>
           <p:nvPr/>
         </p:nvSpPr>
@@ -6371,7 +6119,7 @@
             <a:r>
               <a:rPr sz="1100" b="0">
                 <a:solidFill>
-                  <a:srgbClr val="5A607A"/>
+                  <a:srgbClr val="C9CDDE"/>
                 </a:solidFill>
                 <a:latin typeface="Verdana"/>
               </a:rPr>
@@ -6382,7 +6130,7 @@
       </p:sp>
       <p:sp>
         <p:nvSpPr>
-          <p:cNvPr id="10" name="TextBox 9"/>
+          <p:cNvPr id="9" name="TextBox 8"/>
           <p:cNvSpPr txBox="1"/>
           <p:nvPr/>
         </p:nvSpPr>
@@ -6416,7 +6164,7 @@
             <a:r>
               <a:rPr sz="1100" b="1">
                 <a:solidFill>
-                  <a:srgbClr val="5A607A"/>
+                  <a:srgbClr val="C9CDDE"/>
                 </a:solidFill>
                 <a:latin typeface="Verdana"/>
               </a:rPr>
@@ -6443,9 +6191,33 @@
         <p:nvPr/>
       </p:nvGrpSpPr>
       <p:grpSpPr/>
-      <p:sp>
-        <p:nvSpPr>
-          <p:cNvPr id="2" name="Rectangle 1"/>
+      <p:pic>
+        <p:nvPicPr>
+          <p:cNvPr id="2" name="Picture 1" descr="s7.jpg"/>
+          <p:cNvPicPr>
+            <a:picLocks noChangeAspect="1"/>
+          </p:cNvPicPr>
+          <p:nvPr/>
+        </p:nvPicPr>
+        <p:blipFill>
+          <a:blip r:embed="rId2"/>
+          <a:stretch>
+            <a:fillRect/>
+          </a:stretch>
+        </p:blipFill>
+        <p:spPr>
+          <a:xfrm>
+            <a:off x="0" y="-583175"/>
+            <a:ext cx="12191695" cy="8024351"/>
+          </a:xfrm>
+          <a:prstGeom prst="rect">
+            <a:avLst/>
+          </a:prstGeom>
+        </p:spPr>
+      </p:pic>
+      <p:sp>
+        <p:nvSpPr>
+          <p:cNvPr id="3" name="Rectangle 2"/>
           <p:cNvSpPr/>
           <p:nvPr/>
         </p:nvSpPr>
@@ -6458,7 +6230,9 @@
             <a:avLst/>
           </a:prstGeom>
           <a:solidFill>
-            <a:srgbClr val="161B3A"/>
+            <a:srgbClr val="161B3A">
+              <a:alpha val="62000"/>
+            </a:srgbClr>
           </a:solidFill>
           <a:ln>
             <a:noFill/>
@@ -6489,7 +6263,7 @@
       </p:sp>
       <p:sp>
         <p:nvSpPr>
-          <p:cNvPr id="3" name="TextBox 2"/>
+          <p:cNvPr id="4" name="TextBox 3"/>
           <p:cNvSpPr txBox="1"/>
           <p:nvPr/>
         </p:nvSpPr>
@@ -6534,7 +6308,7 @@
       </p:sp>
       <p:sp>
         <p:nvSpPr>
-          <p:cNvPr id="4" name="TextBox 3"/>
+          <p:cNvPr id="5" name="TextBox 4"/>
           <p:cNvSpPr txBox="1"/>
           <p:nvPr/>
         </p:nvSpPr>
@@ -6580,7 +6354,7 @@
       </p:sp>
       <p:sp>
         <p:nvSpPr>
-          <p:cNvPr id="5" name="Rectangle 4"/>
+          <p:cNvPr id="6" name="Rectangle 5"/>
           <p:cNvSpPr/>
           <p:nvPr/>
         </p:nvSpPr>
@@ -6622,74 +6396,6 @@
           </a:p>
         </p:txBody>
       </p:sp>
-      <p:sp>
-        <p:nvSpPr>
-          <p:cNvPr id="6" name="Oval 5"/>
-          <p:cNvSpPr/>
-          <p:nvPr/>
-        </p:nvSpPr>
-        <p:spPr>
-          <a:xfrm>
-            <a:off x="8138160" y="1371600"/>
-            <a:ext cx="2926080" cy="2926080"/>
-          </a:xfrm>
-          <a:prstGeom prst="ellipse">
-            <a:avLst/>
-          </a:prstGeom>
-          <a:solidFill>
-            <a:srgbClr val="2A315C"/>
-          </a:solidFill>
-          <a:ln>
-            <a:noFill/>
-          </a:ln>
-          <a:effectLst/>
-        </p:spPr>
-        <p:style>
-          <a:lnRef idx="1">
-            <a:schemeClr val="accent1"/>
-          </a:lnRef>
-          <a:fillRef idx="3">
-            <a:schemeClr val="accent1"/>
-          </a:fillRef>
-          <a:effectRef idx="2">
-            <a:schemeClr val="accent1"/>
-          </a:effectRef>
-          <a:fontRef idx="minor">
-            <a:schemeClr val="lt1"/>
-          </a:fontRef>
-        </p:style>
-        <p:txBody>
-          <a:bodyPr rtlCol="0" anchor="ctr"/>
-          <a:lstStyle/>
-          <a:p>
-            <a:pPr algn="ctr"/>
-          </a:p>
-        </p:txBody>
-      </p:sp>
-      <p:pic>
-        <p:nvPicPr>
-          <p:cNvPr id="7" name="Picture 6" descr="2B06.png"/>
-          <p:cNvPicPr>
-            <a:picLocks noChangeAspect="1"/>
-          </p:cNvPicPr>
-          <p:nvPr/>
-        </p:nvPicPr>
-        <p:blipFill>
-          <a:blip r:embed="rId2"/>
-          <a:stretch>
-            <a:fillRect/>
-          </a:stretch>
-        </p:blipFill>
-        <p:spPr>
-          <a:xfrm>
-            <a:off x="8458200" y="1691640"/>
-            <a:ext cx="2286000" cy="2286000"/>
-          </a:xfrm>
-          <a:prstGeom prst="rect">
-            <a:avLst/>
-          </a:prstGeom>
-        </p:spPr>
-      </p:pic>
     </p:spTree>
   </p:cSld>
   <p:clrMapOvr>
@@ -6708,9 +6414,33 @@
         <p:nvPr/>
       </p:nvGrpSpPr>
       <p:grpSpPr/>
-      <p:sp>
-        <p:nvSpPr>
-          <p:cNvPr id="2" name="Rectangle 1"/>
+      <p:pic>
+        <p:nvPicPr>
+          <p:cNvPr id="2" name="Picture 1" descr="s8.jpg"/>
+          <p:cNvPicPr>
+            <a:picLocks noChangeAspect="1"/>
+          </p:cNvPicPr>
+          <p:nvPr/>
+        </p:nvPicPr>
+        <p:blipFill>
+          <a:blip r:embed="rId2"/>
+          <a:stretch>
+            <a:fillRect/>
+          </a:stretch>
+        </p:blipFill>
+        <p:spPr>
+          <a:xfrm>
+            <a:off x="0" y="-1142885"/>
+            <a:ext cx="12191695" cy="9143771"/>
+          </a:xfrm>
+          <a:prstGeom prst="rect">
+            <a:avLst/>
+          </a:prstGeom>
+        </p:spPr>
+      </p:pic>
+      <p:sp>
+        <p:nvSpPr>
+          <p:cNvPr id="3" name="Rectangle 2"/>
           <p:cNvSpPr/>
           <p:nvPr/>
         </p:nvSpPr>
@@ -6723,7 +6453,9 @@
             <a:avLst/>
           </a:prstGeom>
           <a:solidFill>
-            <a:srgbClr val="FFFFFF"/>
+            <a:srgbClr val="161B3A">
+              <a:alpha val="72000"/>
+            </a:srgbClr>
           </a:solidFill>
           <a:ln>
             <a:noFill/>
@@ -6754,7 +6486,7 @@
       </p:sp>
       <p:sp>
         <p:nvSpPr>
-          <p:cNvPr id="3" name="Rectangle 2"/>
+          <p:cNvPr id="4" name="Rectangle 3"/>
           <p:cNvSpPr/>
           <p:nvPr/>
         </p:nvSpPr>
@@ -6798,7 +6530,7 @@
       </p:sp>
       <p:sp>
         <p:nvSpPr>
-          <p:cNvPr id="4" name="TextBox 3"/>
+          <p:cNvPr id="5" name="TextBox 4"/>
           <p:cNvSpPr txBox="1"/>
           <p:nvPr/>
         </p:nvSpPr>
@@ -6832,7 +6564,7 @@
             <a:r>
               <a:rPr sz="3000" b="0">
                 <a:solidFill>
-                  <a:srgbClr val="5A607A"/>
+                  <a:srgbClr val="C9CDDE"/>
                 </a:solidFill>
                 <a:latin typeface="Verdana"/>
               </a:rPr>
@@ -6854,7 +6586,7 @@
             <a:r>
               <a:rPr sz="5600" b="1">
                 <a:solidFill>
-                  <a:srgbClr val="161B3A"/>
+                  <a:srgbClr val="FFFFFF"/>
                 </a:solidFill>
                 <a:latin typeface="Verdana"/>
               </a:rPr>
@@ -6865,7 +6597,7 @@
       </p:sp>
       <p:sp>
         <p:nvSpPr>
-          <p:cNvPr id="5" name="Rectangle 4"/>
+          <p:cNvPr id="6" name="Rectangle 5"/>
           <p:cNvSpPr/>
           <p:nvPr/>
         </p:nvSpPr>
@@ -6909,7 +6641,7 @@
       </p:sp>
       <p:sp>
         <p:nvSpPr>
-          <p:cNvPr id="6" name="TextBox 5"/>
+          <p:cNvPr id="7" name="TextBox 6"/>
           <p:cNvSpPr txBox="1"/>
           <p:nvPr/>
         </p:nvSpPr>
@@ -6954,7 +6686,7 @@
       </p:sp>
       <p:sp>
         <p:nvSpPr>
-          <p:cNvPr id="7" name="Rectangle 6"/>
+          <p:cNvPr id="8" name="Rectangle 7"/>
           <p:cNvSpPr/>
           <p:nvPr/>
         </p:nvSpPr>
@@ -6998,7 +6730,7 @@
       </p:sp>
       <p:sp>
         <p:nvSpPr>
-          <p:cNvPr id="8" name="TextBox 7"/>
+          <p:cNvPr id="9" name="TextBox 8"/>
           <p:cNvSpPr txBox="1"/>
           <p:nvPr/>
         </p:nvSpPr>
@@ -7043,75 +6775,7 @@
       </p:sp>
       <p:sp>
         <p:nvSpPr>
-          <p:cNvPr id="9" name="Oval 8"/>
-          <p:cNvSpPr/>
-          <p:nvPr/>
-        </p:nvSpPr>
-        <p:spPr>
-          <a:xfrm>
-            <a:off x="9769449" y="1265529"/>
-            <a:ext cx="2223820" cy="2223820"/>
-          </a:xfrm>
-          <a:prstGeom prst="ellipse">
-            <a:avLst/>
-          </a:prstGeom>
-          <a:solidFill>
-            <a:srgbClr val="FCE7CF"/>
-          </a:solidFill>
-          <a:ln>
-            <a:noFill/>
-          </a:ln>
-          <a:effectLst/>
-        </p:spPr>
-        <p:style>
-          <a:lnRef idx="1">
-            <a:schemeClr val="accent1"/>
-          </a:lnRef>
-          <a:fillRef idx="3">
-            <a:schemeClr val="accent1"/>
-          </a:fillRef>
-          <a:effectRef idx="2">
-            <a:schemeClr val="accent1"/>
-          </a:effectRef>
-          <a:fontRef idx="minor">
-            <a:schemeClr val="lt1"/>
-          </a:fontRef>
-        </p:style>
-        <p:txBody>
-          <a:bodyPr rtlCol="0" anchor="ctr"/>
-          <a:lstStyle/>
-          <a:p>
-            <a:pPr algn="ctr"/>
-          </a:p>
-        </p:txBody>
-      </p:sp>
-      <p:pic>
-        <p:nvPicPr>
-          <p:cNvPr id="10" name="Picture 9" descr="1F5F3.png"/>
-          <p:cNvPicPr>
-            <a:picLocks noChangeAspect="1"/>
-          </p:cNvPicPr>
-          <p:nvPr/>
-        </p:nvPicPr>
-        <p:blipFill>
-          <a:blip r:embed="rId2"/>
-          <a:stretch>
-            <a:fillRect/>
-          </a:stretch>
-        </p:blipFill>
-        <p:spPr>
-          <a:xfrm>
-            <a:off x="10012680" y="1508760"/>
-            <a:ext cx="1737360" cy="1737360"/>
-          </a:xfrm>
-          <a:prstGeom prst="rect">
-            <a:avLst/>
-          </a:prstGeom>
-        </p:spPr>
-      </p:pic>
-      <p:sp>
-        <p:nvSpPr>
-          <p:cNvPr id="11" name="TextBox 10"/>
+          <p:cNvPr id="10" name="TextBox 9"/>
           <p:cNvSpPr txBox="1"/>
           <p:nvPr/>
         </p:nvSpPr>
@@ -7145,7 +6809,7 @@
             <a:r>
               <a:rPr sz="1100" b="0">
                 <a:solidFill>
-                  <a:srgbClr val="5A607A"/>
+                  <a:srgbClr val="C9CDDE"/>
                 </a:solidFill>
                 <a:latin typeface="Verdana"/>
               </a:rPr>
@@ -7156,7 +6820,7 @@
       </p:sp>
       <p:sp>
         <p:nvSpPr>
-          <p:cNvPr id="12" name="TextBox 11"/>
+          <p:cNvPr id="11" name="TextBox 10"/>
           <p:cNvSpPr txBox="1"/>
           <p:nvPr/>
         </p:nvSpPr>
@@ -7190,7 +6854,7 @@
             <a:r>
               <a:rPr sz="1100" b="1">
                 <a:solidFill>
-                  <a:srgbClr val="5A607A"/>
+                  <a:srgbClr val="C9CDDE"/>
                 </a:solidFill>
                 <a:latin typeface="Verdana"/>
               </a:rPr>

</xml_diff>